<commit_message>
Faster pages, beginner-friendly slides (EN + FR)
</commit_message>
<xml_diff>
--- a/docs/fr/slides.pptx
+++ b/docs/fr/slides.pptx
@@ -22,6 +22,11 @@
     <p:sldId id="270" r:id="rId22"/>
     <p:sldId id="271" r:id="rId23"/>
     <p:sldId id="272" r:id="rId24"/>
+    <p:sldId id="273" r:id="rId25"/>
+    <p:sldId id="274" r:id="rId26"/>
+    <p:sldId id="275" r:id="rId27"/>
+    <p:sldId id="276" r:id="rId28"/>
+    <p:sldId id="277" r:id="rId29"/>
   </p:sldIdLst>
   <p:sldSz cx="12191695" cy="6858000" type="screen4x3"/>
   <p:notesSz cx="6858000" cy="9144000"/>
@@ -518,7 +523,7 @@
           <a:lstStyle/>
           <a:p>
             <a:r>
-              <a:t>Avant de fusionner des cellules ou de réduire une netlist, il faut savoir lesquelles vont ensemble. Ce score, c'est l'affinité. Vous allez comparer le poids d'arête et le score par voisins communs. Les deux sont testés sur le même petit graphe, pour voir qui fusionne en premier. Ensuite, vous verrez un graphe où ces deux scores ne sont pas d'accord. Enfin, un troisième score traite les vraies netlists, où un seul net touche de nombreuses cellules.</a:t>
+              <a:t>Quelles parties d'une puce vont ensemble ? C'est la question à laquelle répond ce lab. Une puce est faite de millions de minuscules éléments appelés cellules. Avant de les placer, un ordinateur doit savoir quelles cellules aiment rester proches. Cette attirance est un nombre, qu'on appelle l'affinité. Dans ce lab, vous allez découvrir trois façons de la calculer, et voir pourquoi ce choix compte.</a:t>
             </a:r>
           </a:p>
         </p:txBody>
@@ -588,7 +593,7 @@
           <a:lstStyle/>
           <a:p>
             <a:r>
-              <a:t>Les vraies netlists ne sont pas faites de simples arêtes. Un seul net peut relier de nombreuses cellules, comme une ligne de reset ou d'enable. Compter chaque net partagé à plein poids rapproche A et B à tort. Elles semblent proches simplement parce qu'elles voient toutes les deux le reset. Le score par nombre de broches corrige cela. Chaque net divise son poids par son nombre de broches moins un. Un net à deux broches compte donc entièrement. Un net à cinq broches ne donne qu'un quart à chaque paire.</a:t>
+              <a:t>Calculons un score ensemble, étape par étape. Étape un : l'arête directe A–C a un poids de un. Étape deux : A et C ont un voisin en commun, B. Les liens qui passent par B pèsent cinq et quatre, on garde le plus petit : quatre. Étape trois : on additionne, un plus quatre font cinq. Seule, A–C était faible, mais elle devient forte grâce à son ami commun.</a:t>
             </a:r>
           </a:p>
         </p:txBody>
@@ -658,7 +663,7 @@
           <a:lstStyle/>
           <a:p>
             <a:r>
-              <a:t>Dans le lab du navigateur, c'est vous qui calculez les scores. Cliquez sur deux nœuds pour choisir une paire, même une paire sans arête, calculez son score à la main, puis saisissez-le. Vous pouvez aussi construire votre propre classement, une paire à la fois, et modifier les poids des arêtes pour voir quelle paire fusionne en premier. Vous pouvez passer d'un graphe à l'autre et d'un score à l'autre. Les dix défis vérifient ce que vous avez saisi, votre classement et vos modifications. Le détail du calcul et le classement complet sont là pour réviser, mais tout ce qu'ils révèlent ne compte plus.</a:t>
+              <a:t>Avec la deuxième recette, notre petit graphe donne dix paires au lieu de six. Quatre d'entre elles n'ont aucun fil entre elles. Par exemple, B et D ne sont pas reliés, mais tous les deux sont reliés à C. B–D obtient donc le plus faible de ces deux liens : deux. C'est comme deux personnes qui ne se sont jamais vues mais ont le même meilleur ami. Seules les paires dont le score vaudrait zéro sont exclues.</a:t>
             </a:r>
           </a:p>
         </p:txBody>
@@ -728,7 +733,7 @@
           <a:lstStyle/>
           <a:p>
             <a:r>
-              <a:t>Dans le parcours implémentation, affichez les deux classements pour le graphe de départ, puis pour le graphe de priorité, et comparez la première ligne de chaque tableau. Ensuite, écrivez vos propres fonctions de score, y compris le nombre de broches, et lancez le vérificateur sur votre fichier. Il contrôle les trois scores, et il fournit les arêtes dans le désordre : un départage oublié apparaît donc comme un échec.</a:t>
+              <a:t>Voici la deuxième recette écrite sous forme d'étapes qu'un ordinateur peut suivre. D'abord, chaque arête ajoute son poids à sa propre paire. Ensuite, pour chaque paire de nœuds, on regarde chaque voisin qu'ils ont en commun. Pour chaque voisin commun, on ajoute le plus petit de ses deux liens. On garde chaque paire dont le score finit au-dessus de zéro. Enfin, on trie par score décroissant et on départage les égalités par ordre alphabétique.</a:t>
             </a:r>
           </a:p>
         </p:txBody>
@@ -798,7 +803,7 @@
           <a:lstStyle/>
           <a:p>
             <a:r>
-              <a:t>Attention à quatre choses. Compter deux fois une arête non orientée, une fois depuis chaque extrémité. Ajouter le plus grand rayon au lieu du plus petit, ce qui rend tout proche de tout. Oublier le départage : A–B et D–E changent alors de place d'une exécution à l'autre. Et compter les nets bruts sur une netlist. Des nets très larges comme le reset collent alors des cellules sans rapport.</a:t>
+              <a:t>Voici un deuxième exemple qui montre pourquoi la recette compte. Prenons un triangle serré P, Q, R, dont chaque arête pèse quatre. À côté, une paire isolée X–Y a un poids de cinq. La première recette choisit X–Y, car cinq bat quatre. La deuxième donne à P–Q quatre, plus quatre via R : huit. P–Q passe donc en premier. Même graphe, même règle de fusion, mais une première fusion différente.</a:t>
             </a:r>
           </a:p>
         </p:txBody>
@@ -868,7 +873,357 @@
           <a:lstStyle/>
           <a:p>
             <a:r>
-              <a:t>Faites passer les trois vérifications de référence. Puis expliquez pourquoi A–C monte avec le score par voisins communs. Expliquez aussi pourquoi le graphe de priorité change sa première fusion. Faites le petit quiz. Passez ensuite à la fusion gloutonne par paires, où ces scores deviennent la règle.</a:t>
+              <a:t>Sur une vraie puce, un même fil peut relier plusieurs cellules à la fois. Un tel fil partagé s'appelle un net, et chaque cellule qu'il touche est une broche. Pensez à une discussion de groupe à cinquante : elle en dit peu sur qui est ami avec qui. Un message privé entre deux personnes en dit beaucoup plus. La troisième recette fonctionne pareil : chaque net partage son poids entre ses broches. La règle : le poids divisé par le nombre de broches moins un. Ici, les nets enable et reset touchent cinq cellules chacun, ils ne donnent donc qu'un quart à chaque paire. Le net privé entre E et F donne tout son poids, c'est-à-dire un.</a:t>
+            </a:r>
+          </a:p>
+        </p:txBody>
+      </p:sp>
+      <p:sp>
+        <p:nvSpPr>
+          <p:cNvPr id="4" name="Slide Number Placeholder 3"/>
+          <p:cNvSpPr>
+            <a:spLocks noGrp="1"/>
+          </p:cNvSpPr>
+          <p:nvPr>
+            <p:ph type="sldNum" idx="5" sz="quarter"/>
+          </p:nvPr>
+        </p:nvSpPr>
+        <p:spPr/>
+      </p:sp>
+    </p:spTree>
+  </p:cSld>
+  <p:clrMapOvr>
+    <a:masterClrMapping/>
+  </p:clrMapOvr>
+</p:notes>
+</file>
+
+<file path=ppt/notesSlides/notesSlide15.xml><?xml version="1.0" encoding="utf-8"?>
+<p:notes xmlns:a="http://schemas.openxmlformats.org/drawingml/2006/main" xmlns:p="http://schemas.openxmlformats.org/presentationml/2006/main" xmlns:r="http://schemas.openxmlformats.org/officeDocument/2006/relationships">
+  <p:cSld>
+    <p:spTree>
+      <p:nvGrpSpPr>
+        <p:cNvPr id="1" name=""/>
+        <p:cNvGrpSpPr/>
+        <p:nvPr/>
+      </p:nvGrpSpPr>
+      <p:grpSpPr>
+        <a:xfrm>
+          <a:off x="0" y="0"/>
+          <a:ext cx="0" cy="0"/>
+          <a:chOff x="0" y="0"/>
+          <a:chExt cx="0" cy="0"/>
+        </a:xfrm>
+      </p:grpSpPr>
+      <p:sp>
+        <p:nvSpPr>
+          <p:cNvPr id="2" name="Slide Image Placeholder 1"/>
+          <p:cNvSpPr>
+            <a:spLocks noGrp="1"/>
+          </p:cNvSpPr>
+          <p:nvPr>
+            <p:ph type="sldImg" idx="2"/>
+          </p:nvPr>
+        </p:nvSpPr>
+        <p:spPr/>
+      </p:sp>
+      <p:sp>
+        <p:nvSpPr>
+          <p:cNvPr id="3" name="Notes Placeholder 2"/>
+          <p:cNvSpPr>
+            <a:spLocks noGrp="1"/>
+          </p:cNvSpPr>
+          <p:nvPr>
+            <p:ph type="body" idx="3" sz="quarter"/>
+          </p:nvPr>
+        </p:nvSpPr>
+        <p:spPr/>
+        <p:txBody>
+          <a:bodyPr/>
+          <a:lstStyle/>
+          <a:p>
+            <a:r>
+              <a:t>À vous maintenant de calculer des scores, dans le lab du navigateur. Cliquez sur deux nœuds pour choisir une paire, même une paire sans arête, calculez son score à la main, puis saisissez-le. Le lab vous dit tout de suite si c'est juste. Vous pouvez aussi construire votre propre classement, une paire à la fois, et modifier les poids des arêtes pour voir quelle paire fusionne en premier. Les dix défis vont du plus facile au plus difficile. Si vous bloquez, le bouton de détail montre le calcul, mais cette réponse ne compte plus pour le défi.</a:t>
+            </a:r>
+          </a:p>
+        </p:txBody>
+      </p:sp>
+      <p:sp>
+        <p:nvSpPr>
+          <p:cNvPr id="4" name="Slide Number Placeholder 3"/>
+          <p:cNvSpPr>
+            <a:spLocks noGrp="1"/>
+          </p:cNvSpPr>
+          <p:nvPr>
+            <p:ph type="sldNum" idx="5" sz="quarter"/>
+          </p:nvPr>
+        </p:nvSpPr>
+        <p:spPr/>
+      </p:sp>
+    </p:spTree>
+  </p:cSld>
+  <p:clrMapOvr>
+    <a:masterClrMapping/>
+  </p:clrMapOvr>
+</p:notes>
+</file>
+
+<file path=ppt/notesSlides/notesSlide16.xml><?xml version="1.0" encoding="utf-8"?>
+<p:notes xmlns:a="http://schemas.openxmlformats.org/drawingml/2006/main" xmlns:p="http://schemas.openxmlformats.org/presentationml/2006/main" xmlns:r="http://schemas.openxmlformats.org/officeDocument/2006/relationships">
+  <p:cSld>
+    <p:spTree>
+      <p:nvGrpSpPr>
+        <p:cNvPr id="1" name=""/>
+        <p:cNvGrpSpPr/>
+        <p:nvPr/>
+      </p:nvGrpSpPr>
+      <p:grpSpPr>
+        <a:xfrm>
+          <a:off x="0" y="0"/>
+          <a:ext cx="0" cy="0"/>
+          <a:chOff x="0" y="0"/>
+          <a:chExt cx="0" cy="0"/>
+        </a:xfrm>
+      </p:grpSpPr>
+      <p:sp>
+        <p:nvSpPr>
+          <p:cNvPr id="2" name="Slide Image Placeholder 1"/>
+          <p:cNvSpPr>
+            <a:spLocks noGrp="1"/>
+          </p:cNvSpPr>
+          <p:nvPr>
+            <p:ph type="sldImg" idx="2"/>
+          </p:nvPr>
+        </p:nvSpPr>
+        <p:spPr/>
+      </p:sp>
+      <p:sp>
+        <p:nvSpPr>
+          <p:cNvPr id="3" name="Notes Placeholder 2"/>
+          <p:cNvSpPr>
+            <a:spLocks noGrp="1"/>
+          </p:cNvSpPr>
+          <p:nvPr>
+            <p:ph type="body" idx="3" sz="quarter"/>
+          </p:nvPr>
+        </p:nvSpPr>
+        <p:spPr/>
+        <p:txBody>
+          <a:bodyPr/>
+          <a:lstStyle/>
+          <a:p>
+            <a:r>
+              <a:t>Si vous aimez programmer, le parcours implémentation est fait pour vous. D'abord, affichez les deux classements avec le programme de référence, pour le graphe de départ puis pour le graphe de priorité. Ensuite, écrivez vos trois fonctions de score en Python. Enfin, lancez le vérificateur sur votre fichier. Il compare vos réponses aux bonnes, et il fournit les arêtes dans le désordre : un départage oublié apparaît donc comme un échec.</a:t>
+            </a:r>
+          </a:p>
+        </p:txBody>
+      </p:sp>
+      <p:sp>
+        <p:nvSpPr>
+          <p:cNvPr id="4" name="Slide Number Placeholder 3"/>
+          <p:cNvSpPr>
+            <a:spLocks noGrp="1"/>
+          </p:cNvSpPr>
+          <p:nvPr>
+            <p:ph type="sldNum" idx="5" sz="quarter"/>
+          </p:nvPr>
+        </p:nvSpPr>
+        <p:spPr/>
+      </p:sp>
+    </p:spTree>
+  </p:cSld>
+  <p:clrMapOvr>
+    <a:masterClrMapping/>
+  </p:clrMapOvr>
+</p:notes>
+</file>
+
+<file path=ppt/notesSlides/notesSlide17.xml><?xml version="1.0" encoding="utf-8"?>
+<p:notes xmlns:a="http://schemas.openxmlformats.org/drawingml/2006/main" xmlns:p="http://schemas.openxmlformats.org/presentationml/2006/main" xmlns:r="http://schemas.openxmlformats.org/officeDocument/2006/relationships">
+  <p:cSld>
+    <p:spTree>
+      <p:nvGrpSpPr>
+        <p:cNvPr id="1" name=""/>
+        <p:cNvGrpSpPr/>
+        <p:nvPr/>
+      </p:nvGrpSpPr>
+      <p:grpSpPr>
+        <a:xfrm>
+          <a:off x="0" y="0"/>
+          <a:ext cx="0" cy="0"/>
+          <a:chOff x="0" y="0"/>
+          <a:chExt cx="0" cy="0"/>
+        </a:xfrm>
+      </p:grpSpPr>
+      <p:sp>
+        <p:nvSpPr>
+          <p:cNvPr id="2" name="Slide Image Placeholder 1"/>
+          <p:cNvSpPr>
+            <a:spLocks noGrp="1"/>
+          </p:cNvSpPr>
+          <p:nvPr>
+            <p:ph type="sldImg" idx="2"/>
+          </p:nvPr>
+        </p:nvSpPr>
+        <p:spPr/>
+      </p:sp>
+      <p:sp>
+        <p:nvSpPr>
+          <p:cNvPr id="3" name="Notes Placeholder 2"/>
+          <p:cNvSpPr>
+            <a:spLocks noGrp="1"/>
+          </p:cNvSpPr>
+          <p:nvPr>
+            <p:ph type="body" idx="3" sz="quarter"/>
+          </p:nvPr>
+        </p:nvSpPr>
+        <p:spPr/>
+        <p:txBody>
+          <a:bodyPr/>
+          <a:lstStyle/>
+          <a:p>
+            <a:r>
+              <a:t>Attention à quatre erreurs fréquentes. Compter deux fois une arête, une fois depuis chaque extrémité. Ajouter le lien le plus fort au lieu du plus faible : tout semble alors proche de tout. Oublier le départage : A–B et D–E changent de place d'une exécution à l'autre. Et compter les grands nets partagés à plein poids, ce qui colle des cellules sans rapport.</a:t>
+            </a:r>
+          </a:p>
+        </p:txBody>
+      </p:sp>
+      <p:sp>
+        <p:nvSpPr>
+          <p:cNvPr id="4" name="Slide Number Placeholder 3"/>
+          <p:cNvSpPr>
+            <a:spLocks noGrp="1"/>
+          </p:cNvSpPr>
+          <p:nvPr>
+            <p:ph type="sldNum" idx="5" sz="quarter"/>
+          </p:nvPr>
+        </p:nvSpPr>
+        <p:spPr/>
+      </p:sp>
+    </p:spTree>
+  </p:cSld>
+  <p:clrMapOvr>
+    <a:masterClrMapping/>
+  </p:clrMapOvr>
+</p:notes>
+</file>
+
+<file path=ppt/notesSlides/notesSlide18.xml><?xml version="1.0" encoding="utf-8"?>
+<p:notes xmlns:a="http://schemas.openxmlformats.org/drawingml/2006/main" xmlns:p="http://schemas.openxmlformats.org/presentationml/2006/main" xmlns:r="http://schemas.openxmlformats.org/officeDocument/2006/relationships">
+  <p:cSld>
+    <p:spTree>
+      <p:nvGrpSpPr>
+        <p:cNvPr id="1" name=""/>
+        <p:cNvGrpSpPr/>
+        <p:nvPr/>
+      </p:nvGrpSpPr>
+      <p:grpSpPr>
+        <a:xfrm>
+          <a:off x="0" y="0"/>
+          <a:ext cx="0" cy="0"/>
+          <a:chOff x="0" y="0"/>
+          <a:chExt cx="0" cy="0"/>
+        </a:xfrm>
+      </p:grpSpPr>
+      <p:sp>
+        <p:nvSpPr>
+          <p:cNvPr id="2" name="Slide Image Placeholder 1"/>
+          <p:cNvSpPr>
+            <a:spLocks noGrp="1"/>
+          </p:cNvSpPr>
+          <p:nvPr>
+            <p:ph type="sldImg" idx="2"/>
+          </p:nvPr>
+        </p:nvSpPr>
+        <p:spPr/>
+      </p:sp>
+      <p:sp>
+        <p:nvSpPr>
+          <p:cNvPr id="3" name="Notes Placeholder 2"/>
+          <p:cNvSpPr>
+            <a:spLocks noGrp="1"/>
+          </p:cNvSpPr>
+          <p:nvPr>
+            <p:ph type="body" idx="3" sz="quarter"/>
+          </p:nvPr>
+        </p:nvSpPr>
+        <p:spPr/>
+        <p:txBody>
+          <a:bodyPr/>
+          <a:lstStyle/>
+          <a:p>
+            <a:r>
+              <a:t>Recette un, le poids d'arête : on ne regarde que le fil direct. Recette deux, les voisins communs : on ajoute l'aide des amis communs. Recette trois, le nombre de broches : un grand net partagé compte moins qu'un net privé. Les égalités se départagent par ordre alphabétique, donc les résultats ne changent jamais. Des recettes différentes peuvent choisir une première fusion différente. Choisir la recette est une décision de conception, pas un détail.</a:t>
+            </a:r>
+          </a:p>
+        </p:txBody>
+      </p:sp>
+      <p:sp>
+        <p:nvSpPr>
+          <p:cNvPr id="4" name="Slide Number Placeholder 3"/>
+          <p:cNvSpPr>
+            <a:spLocks noGrp="1"/>
+          </p:cNvSpPr>
+          <p:nvPr>
+            <p:ph type="sldNum" idx="5" sz="quarter"/>
+          </p:nvPr>
+        </p:nvSpPr>
+        <p:spPr/>
+      </p:sp>
+    </p:spTree>
+  </p:cSld>
+  <p:clrMapOvr>
+    <a:masterClrMapping/>
+  </p:clrMapOvr>
+</p:notes>
+</file>
+
+<file path=ppt/notesSlides/notesSlide19.xml><?xml version="1.0" encoding="utf-8"?>
+<p:notes xmlns:a="http://schemas.openxmlformats.org/drawingml/2006/main" xmlns:p="http://schemas.openxmlformats.org/presentationml/2006/main" xmlns:r="http://schemas.openxmlformats.org/officeDocument/2006/relationships">
+  <p:cSld>
+    <p:spTree>
+      <p:nvGrpSpPr>
+        <p:cNvPr id="1" name=""/>
+        <p:cNvGrpSpPr/>
+        <p:nvPr/>
+      </p:nvGrpSpPr>
+      <p:grpSpPr>
+        <a:xfrm>
+          <a:off x="0" y="0"/>
+          <a:ext cx="0" cy="0"/>
+          <a:chOff x="0" y="0"/>
+          <a:chExt cx="0" cy="0"/>
+        </a:xfrm>
+      </p:grpSpPr>
+      <p:sp>
+        <p:nvSpPr>
+          <p:cNvPr id="2" name="Slide Image Placeholder 1"/>
+          <p:cNvSpPr>
+            <a:spLocks noGrp="1"/>
+          </p:cNvSpPr>
+          <p:nvPr>
+            <p:ph type="sldImg" idx="2"/>
+          </p:nvPr>
+        </p:nvSpPr>
+        <p:spPr/>
+      </p:sp>
+      <p:sp>
+        <p:nvSpPr>
+          <p:cNvPr id="3" name="Notes Placeholder 2"/>
+          <p:cNvSpPr>
+            <a:spLocks noGrp="1"/>
+          </p:cNvSpPr>
+          <p:nvPr>
+            <p:ph type="body" idx="3" sz="quarter"/>
+          </p:nvPr>
+        </p:nvSpPr>
+        <p:spPr/>
+        <p:txBody>
+          <a:bodyPr/>
+          <a:lstStyle/>
+          <a:p>
+            <a:r>
+              <a:t>Essayez les défis du lab, ou écrivez les trois recettes et passez le vérificateur. Puis expliquez deux choses avec vos propres mots. D'abord, pourquoi A–C monte-t-elle avec la deuxième recette ? Ensuite, pourquoi le graphe de priorité change-t-il sa première fusion ? Faites le petit quiz, puis passez à la fusion gloutonne par paires. Là, ces scores deviennent la règle de fusion.</a:t>
             </a:r>
           </a:p>
         </p:txBody>
@@ -938,7 +1293,7 @@
           <a:lstStyle/>
           <a:p>
             <a:r>
-              <a:t>Cinq cellules, de A à E, reliées par des arêtes pondérées. Les arêtes lourdes A–B et D–E pèsent toutes les deux cinq ; le pont qui passe par C est plus faible. C'est l'affinité qui va décider quelles paires veulent former un cluster en premier.</a:t>
+              <a:t>Une puce contient des cellules, les petites briques du circuit. Les cellules communiquent entre elles par des fils. On dessine chaque cellule comme un point, appelé nœud. Un trait entre deux points est une arête : les deux cellules sont reliées. Le nombre sur une arête est son poids : combien de fils relient la paire. Ainsi, A–B a un poids de cinq : cinq fils relient A et B. Ce dessin s'appelle un graphe, et c'est la carte sur laquelle travaillent tous les algorithmes de ce cours.</a:t>
             </a:r>
           </a:p>
         </p:txBody>
@@ -1008,7 +1363,7 @@
           <a:lstStyle/>
           <a:p>
             <a:r>
-              <a:t>L'affinité par poids d'arête se contente de trier les arêtes existantes. A–B et D–E sont à égalité à cinq ; le départage place A–B en premier. Ce classement est la priorité de fusion la plus simple.</a:t>
+              <a:t>Les cellules qui échangent beaucoup de signaux doivent être proches. Des fils courts rendent la puce plus rapide et économisent de l'énergie. Regrouper les cellules proches s'appelle le clustering, et chaque groupe est un cluster. Pensez à un plan de classe : les amis qui discutent beaucoup s'assoient ensemble. Ici, A, B et C forment un groupe, et D et E en forment un autre. Seules les arêtes rouges passent d'un groupe à l'autre, et on en veut le moins possible.</a:t>
             </a:r>
           </a:p>
         </p:txBody>
@@ -1078,7 +1433,7 @@
           <a:lstStyle/>
           <a:p>
             <a:r>
-              <a:t>A et B partagent déjà une arête de poids cinq. Ils ont aussi un voisin commun : C. L'affinité par voisins communs ajoute le plus petit des deux rayons, c'est-à-dire un, donc A–B monte à six.</a:t>
+              <a:t>L'affinité est un score donné à chaque paire de cellules. Un score élevé veut dire que ces deux-là doivent être dans le même groupe. Un score faible veut dire qu'elles peuvent être séparées. Les algorithmes de clustering fusionnent d'abord la paire qui a le meilleur score. La recette du score décide donc de tout ce qui suit. Ce lab compare trois recettes sur le même petit exemple.</a:t>
             </a:r>
           </a:p>
         </p:txBody>
@@ -1148,7 +1503,7 @@
           <a:lstStyle/>
           <a:p>
             <a:r>
-              <a:t>Avec le score par voisins communs, A–B et D–E mènent à six. L'arête faible A–C bondit à cinq grâce à B. Des paires sans arête, comme B–D, peuvent apparaître uniquement grâce à leurs voisins communs.</a:t>
+              <a:t>Voici notre exemple pour tout le lab : cinq cellules, de A à E. Les arêtes lourdes sont A–B et D–E, avec un poids de cinq chacune. C est au milieu, avec des liens plus fins vers les autres. Gardez cette image en tête : nous allons donner un score à chaque paire de cellules de ce graphe.</a:t>
             </a:r>
           </a:p>
         </p:txBody>
@@ -1218,7 +1573,7 @@
           <a:lstStyle/>
           <a:p>
             <a:r>
-              <a:t>L'affinité, c'est la préférence locale de l'objectif : quelles cellules vont ensemble, avant les contraintes globales. Une mauvaise affinité donne de mauvaises fusions, et un raffinement plus difficile ensuite.</a:t>
+              <a:t>La première recette est la plus simple. Le score d'une paire est simplement le poids de l'arête qui les relie. Ensuite, on trie les paires du plus grand au plus petit score, comme un classement sportif. A–B et D–E sont à égalité, à cinq. Quand deux scores sont égaux, on les départage par ordre alphabétique : A–B passe donc en premier. Ce départage fixe est important : il garantit que l'ordinateur donne toujours la même réponse.</a:t>
             </a:r>
           </a:p>
         </p:txBody>
@@ -1288,7 +1643,7 @@
           <a:lstStyle/>
           <a:p>
             <a:r>
-              <a:t>Voici le score par voisins communs sous forme de code. D'abord, chaque arête existante ajoute son poids à sa paire. Ensuite, on prend chaque paire de nœuds et chacun de leurs voisins communs. Pour chaque voisin commun, on ajoute le plus petit des deux poids vers la paire. Une paire dont le score dépasse zéro est gardée. Enfin, on trie par score décroissant, et on départage les égalités par ordre alphabétique. Ainsi, la liste est toujours la même.</a:t>
+              <a:t>La deuxième recette ajoute une idée de la vie de tous les jours : les amis de nos amis. Si deux personnes ont un ami proche en commun, elles sont sans doute proches aussi. A et B sont reliés directement, avec un poids de cinq. Ils ont aussi un voisin en commun : C. On ajoute le plus faible des deux liens qui passent par C, c'est-à-dire un, donc A–B monte à six. Pourquoi le plus faible ? Parce qu'une chaîne n'est jamais plus solide que son maillon le plus faible.</a:t>
             </a:r>
           </a:p>
         </p:txBody>
@@ -1358,7 +1713,7 @@
           <a:lstStyle/>
           <a:p>
             <a:r>
-              <a:t>Avec le score par voisins communs, le graphe de départ donne dix paires, et non six. Quatre d'entre elles n'ont aucune arête. B et D sont tous les deux reliés à C, donc B–D obtient le plus petit rayon : deux. A–D, A–E et B–E gagnent chacune un, en passant par C. Ces paires ne sont pas des erreurs. Elles disent que deux cellules sont proches, même sans fil direct. Une paire n'est exclue que si son score vaut zéro.</a:t>
+              <a:t>Avec la deuxième recette, A–B et D–E restent en tête, maintenant à six. Mais regardez A–C : seule, c'était une arête faible de poids un, et maintenant elle bondit à cinq, grâce à B. Même des paires sans aucune arête, comme B–D, obtiennent un score, parce qu'elles ont un voisin en commun.</a:t>
             </a:r>
           </a:p>
         </p:txBody>
@@ -1428,7 +1783,7 @@
           <a:lstStyle/>
           <a:p>
             <a:r>
-              <a:t>Prenons un triangle serré P, Q, R, dont chaque arête pèse quatre. Ajoutons une paire isolée X–Y, de poids cinq. Le poids d'arête choisit d'abord X–Y, car cinq bat quatre. Le score par voisins communs donne à P–Q quatre, plus quatre via R : huit. X–Y n'a aucun voisin commun, donc reste à cinq. Même graphe, même moteur de fusion, mais une première fusion différente.</a:t>
+              <a:t>EDA signifie conception électronique automatisée : ce sont les logiciels qui conçoivent les puces. En EDA, l'affinité est la préférence locale : quelles cellules vont ensemble, avant toute règle sur la puce entière. Une mauvaise affinité donne de mauvaises fusions, et les corriger ensuite est bien plus difficile.</a:t>
             </a:r>
           </a:p>
         </p:txBody>
@@ -4490,7 +4845,7 @@
                 </a:solidFill>
                 <a:latin typeface="Calibri"/>
               </a:rPr>
-              <a:t>Avant de fusionner des cellules ou de réduire une netlist, il faut savoir lesquelles vont ensemble</a:t>
+              <a:t>Quelles parties d'une puce vont ensemble ?</a:t>
             </a:r>
           </a:p>
         </p:txBody>
@@ -4586,7 +4941,7 @@
                 </a:solidFill>
                 <a:latin typeface="Calibri"/>
               </a:rPr>
-              <a:t>Même graphe, première fusion différente</a:t>
+              <a:t>Exemple résolu : le score de A–C</a:t>
             </a:r>
           </a:p>
         </p:txBody>
@@ -4631,7 +4986,7 @@
                 </a:solidFill>
                 <a:latin typeface="Calibri"/>
               </a:rPr>
-              <a:t>Prenons un triangle serré P, Q, R, dont chaque arête pèse quatre</a:t>
+              <a:t>Calculons un score ensemble, étape par étape</a:t>
             </a:r>
           </a:p>
           <a:p>
@@ -4653,7 +5008,7 @@
                 </a:solidFill>
                 <a:latin typeface="Calibri"/>
               </a:rPr>
-              <a:t>Ajoutons une paire isolée X–Y, de poids cinq</a:t>
+              <a:t>Étape un : l'arête directe A–C a un poids de un</a:t>
             </a:r>
           </a:p>
           <a:p>
@@ -4675,7 +5030,7 @@
                 </a:solidFill>
                 <a:latin typeface="Calibri"/>
               </a:rPr>
-              <a:t>Le poids d'arête choisit d'abord X–Y, car cinq bat quatre</a:t>
+              <a:t>Étape deux : A et C ont un voisin en commun, B</a:t>
             </a:r>
           </a:p>
           <a:p>
@@ -4697,7 +5052,7 @@
                 </a:solidFill>
                 <a:latin typeface="Calibri"/>
               </a:rPr>
-              <a:t>Le score par voisins communs donne à P–Q quatre, plus quatre via R : huit</a:t>
+              <a:t>Les liens qui passent par B pèsent cinq et quatre, on garde le plus petit : quatre</a:t>
             </a:r>
           </a:p>
           <a:p>
@@ -4719,7 +5074,7 @@
                 </a:solidFill>
                 <a:latin typeface="Calibri"/>
               </a:rPr>
-              <a:t>X–Y n'a aucun voisin commun, donc reste à cinq</a:t>
+              <a:t>Étape trois : on additionne, un plus quatre font cinq</a:t>
             </a:r>
           </a:p>
           <a:p>
@@ -4741,14 +5096,14 @@
                 </a:solidFill>
                 <a:latin typeface="Calibri"/>
               </a:rPr>
-              <a:t>Même graphe, même moteur de fusion, mais une première fusion différente</a:t>
+              <a:t>Seule, A–C était faible, mais elle devient forte grâce à son ami commun</a:t>
             </a:r>
           </a:p>
         </p:txBody>
       </p:sp>
       <p:pic>
         <p:nvPicPr>
-          <p:cNvPr id="4" name="Picture 3" descr="priority-graph.png"/>
+          <p:cNvPr id="4" name="Picture 3" descr="worked-ac.png"/>
           <p:cNvPicPr>
             <a:picLocks noChangeAspect="1"/>
           </p:cNvPicPr>
@@ -4763,7 +5118,7 @@
         <p:spPr>
           <a:xfrm>
             <a:off x="6172200" y="1234440"/>
-            <a:ext cx="3548417" cy="4754879"/>
+            <a:ext cx="5131742" cy="4754880"/>
           </a:xfrm>
           <a:prstGeom prst="rect">
             <a:avLst/>
@@ -4861,7 +5216,7 @@
                 </a:solidFill>
                 <a:latin typeface="Calibri"/>
               </a:rPr>
-              <a:t>Des nets à nombreuses broches</a:t>
+              <a:t>Dix paires, pas six</a:t>
             </a:r>
           </a:p>
         </p:txBody>
@@ -4906,7 +5261,7 @@
                 </a:solidFill>
                 <a:latin typeface="Calibri"/>
               </a:rPr>
-              <a:t>Les vraies netlists ne sont pas faites de simples arêtes</a:t>
+              <a:t>Avec la deuxième recette, notre petit graphe donne dix paires au lieu de six</a:t>
             </a:r>
           </a:p>
           <a:p>
@@ -4928,7 +5283,7 @@
                 </a:solidFill>
                 <a:latin typeface="Calibri"/>
               </a:rPr>
-              <a:t>Un seul net peut relier de nombreuses cellules, comme une ligne de reset ou d'enable</a:t>
+              <a:t>Quatre d'entre elles n'ont aucun fil entre elles</a:t>
             </a:r>
           </a:p>
           <a:p>
@@ -4950,7 +5305,7 @@
                 </a:solidFill>
                 <a:latin typeface="Calibri"/>
               </a:rPr>
-              <a:t>Compter chaque net partagé à plein poids rapproche A et B à tort</a:t>
+              <a:t>Par exemple, B et D ne sont pas reliés, mais tous les deux sont reliés à C</a:t>
             </a:r>
           </a:p>
           <a:p>
@@ -4972,7 +5327,7 @@
                 </a:solidFill>
                 <a:latin typeface="Calibri"/>
               </a:rPr>
-              <a:t>Elles semblent proches simplement parce qu'elles voient toutes les deux le reset</a:t>
+              <a:t>B–D obtient donc le plus faible de ces deux liens : deux</a:t>
             </a:r>
           </a:p>
           <a:p>
@@ -4994,7 +5349,7 @@
                 </a:solidFill>
                 <a:latin typeface="Calibri"/>
               </a:rPr>
-              <a:t>Le score par nombre de broches corrige cela</a:t>
+              <a:t>C'est comme deux personnes qui ne se sont jamais vues mais ont le même meilleur ami</a:t>
             </a:r>
           </a:p>
           <a:p>
@@ -5016,7 +5371,7 @@
                 </a:solidFill>
                 <a:latin typeface="Calibri"/>
               </a:rPr>
-              <a:t>Chaque net divise son poids par son nombre de broches moins un</a:t>
+              <a:t>Seules les paires dont le score vaudrait zéro sont exclues</a:t>
             </a:r>
           </a:p>
         </p:txBody>
@@ -5112,7 +5467,7 @@
                 </a:solidFill>
                 <a:latin typeface="Calibri"/>
               </a:rPr>
-              <a:t>Des nets à nombreuses broches — à essayer</a:t>
+              <a:t>La deuxième recette en pseudo-code</a:t>
             </a:r>
           </a:p>
         </p:txBody>
@@ -5125,15 +5480,13 @@
         </p:nvSpPr>
         <p:spPr>
           <a:xfrm>
-            <a:off x="548640" y="1143000"/>
-            <a:ext cx="11064240" cy="5029200"/>
+            <a:off x="548640" y="1234440"/>
+            <a:ext cx="11064240" cy="4937760"/>
           </a:xfrm>
           <a:prstGeom prst="rect">
             <a:avLst/>
           </a:prstGeom>
-          <a:solidFill>
-            <a:srgbClr val="F4F4F4"/>
-          </a:solidFill>
+          <a:noFill/>
         </p:spPr>
         <p:txBody>
           <a:bodyPr wrap="square">
@@ -5141,117 +5494,135 @@
           </a:bodyPr>
           <a:lstStyle/>
           <a:p>
-            <a:pPr>
-              <a:lnSpc>
-                <a:spcPts val="2200"/>
-              </a:lnSpc>
+            <a:pPr lvl="0" marL="457200" indent="-228600">
+              <a:buFont typeface="Calibri"/>
               <a:spcAft>
-                <a:spcPts val="400"/>
+                <a:spcPts val="1000"/>
               </a:spcAft>
+              <a:buSzPct val="100000"/>
+              <a:buChar char="•"/>
+              <a:lnSpc>
+                <a:spcPts val="2200"/>
+              </a:lnSpc>
             </a:pPr>
             <a:r>
               <a:rPr sz="2000" b="0">
                 <a:solidFill>
                   <a:srgbClr val="333333"/>
                 </a:solidFill>
-                <a:latin typeface="Consolas"/>
-              </a:rPr>
-              <a:t>petite netlist : en {A,B,C,D,E}, rst {A,B,C,D,E}, n1 {E,F}</a:t>
-            </a:r>
-          </a:p>
-          <a:p>
-            <a:pPr>
-              <a:lnSpc>
-                <a:spcPts val="2200"/>
-              </a:lnSpc>
+                <a:latin typeface="Calibri"/>
+              </a:rPr>
+              <a:t>Voici la deuxième recette écrite sous forme d'étapes qu'un ordinateur peut suivre</a:t>
+            </a:r>
+          </a:p>
+          <a:p>
+            <a:pPr lvl="0" marL="457200" indent="-228600">
+              <a:buFont typeface="Calibri"/>
               <a:spcAft>
-                <a:spcPts val="400"/>
+                <a:spcPts val="1000"/>
               </a:spcAft>
+              <a:buSzPct val="100000"/>
+              <a:buChar char="•"/>
+              <a:lnSpc>
+                <a:spcPts val="2200"/>
+              </a:lnSpc>
             </a:pPr>
             <a:r>
               <a:rPr sz="2000" b="0">
                 <a:solidFill>
                   <a:srgbClr val="333333"/>
                 </a:solidFill>
-                <a:latin typeface="Consolas"/>
-              </a:rPr>
-              <a:t/>
-            </a:r>
-          </a:p>
-          <a:p>
-            <a:pPr>
-              <a:lnSpc>
-                <a:spcPts val="2200"/>
-              </a:lnSpc>
+                <a:latin typeface="Calibri"/>
+              </a:rPr>
+              <a:t>D'abord, chaque arête ajoute son poids à sa propre paire</a:t>
+            </a:r>
+          </a:p>
+          <a:p>
+            <a:pPr lvl="0" marL="457200" indent="-228600">
+              <a:buFont typeface="Calibri"/>
               <a:spcAft>
-                <a:spcPts val="400"/>
+                <a:spcPts val="1000"/>
               </a:spcAft>
+              <a:buSzPct val="100000"/>
+              <a:buChar char="•"/>
+              <a:lnSpc>
+                <a:spcPts val="2200"/>
+              </a:lnSpc>
             </a:pPr>
             <a:r>
               <a:rPr sz="2000" b="0">
                 <a:solidFill>
                   <a:srgbClr val="333333"/>
                 </a:solidFill>
-                <a:latin typeface="Consolas"/>
-              </a:rPr>
-              <a:t>           nombre brut de nets    nombre de broches w/(|e|-1)</a:t>
-            </a:r>
-          </a:p>
-          <a:p>
-            <a:pPr>
-              <a:lnSpc>
-                <a:spcPts val="2200"/>
-              </a:lnSpc>
+                <a:latin typeface="Calibri"/>
+              </a:rPr>
+              <a:t>Ensuite, pour chaque paire de nœuds, on regarde chaque voisin qu'ils ont en commun</a:t>
+            </a:r>
+          </a:p>
+          <a:p>
+            <a:pPr lvl="0" marL="457200" indent="-228600">
+              <a:buFont typeface="Calibri"/>
               <a:spcAft>
-                <a:spcPts val="400"/>
+                <a:spcPts val="1000"/>
               </a:spcAft>
+              <a:buSzPct val="100000"/>
+              <a:buChar char="•"/>
+              <a:lnSpc>
+                <a:spcPts val="2200"/>
+              </a:lnSpc>
             </a:pPr>
             <a:r>
               <a:rPr sz="2000" b="0">
                 <a:solidFill>
                   <a:srgbClr val="333333"/>
                 </a:solidFill>
-                <a:latin typeface="Consolas"/>
-              </a:rPr>
-              <a:t>A-B        1 + 1 = 2              1/4 + 1/4 = 0.5</a:t>
-            </a:r>
-          </a:p>
-          <a:p>
-            <a:pPr>
-              <a:lnSpc>
-                <a:spcPts val="2200"/>
-              </a:lnSpc>
+                <a:latin typeface="Calibri"/>
+              </a:rPr>
+              <a:t>Pour chaque voisin commun, on ajoute le plus petit de ses deux liens</a:t>
+            </a:r>
+          </a:p>
+          <a:p>
+            <a:pPr lvl="0" marL="457200" indent="-228600">
+              <a:buFont typeface="Calibri"/>
               <a:spcAft>
-                <a:spcPts val="400"/>
+                <a:spcPts val="1000"/>
               </a:spcAft>
+              <a:buSzPct val="100000"/>
+              <a:buChar char="•"/>
+              <a:lnSpc>
+                <a:spcPts val="2200"/>
+              </a:lnSpc>
             </a:pPr>
             <a:r>
               <a:rPr sz="2000" b="0">
                 <a:solidFill>
                   <a:srgbClr val="333333"/>
                 </a:solidFill>
-                <a:latin typeface="Consolas"/>
-              </a:rPr>
-              <a:t>E-F        1                      1/1 = 1.0</a:t>
-            </a:r>
-          </a:p>
-          <a:p>
-            <a:pPr>
-              <a:lnSpc>
-                <a:spcPts val="2200"/>
-              </a:lnSpc>
+                <a:latin typeface="Calibri"/>
+              </a:rPr>
+              <a:t>On garde chaque paire dont le score finit au-dessus de zéro</a:t>
+            </a:r>
+          </a:p>
+          <a:p>
+            <a:pPr lvl="0" marL="457200" indent="-228600">
+              <a:buFont typeface="Calibri"/>
               <a:spcAft>
-                <a:spcPts val="400"/>
+                <a:spcPts val="1000"/>
               </a:spcAft>
+              <a:buSzPct val="100000"/>
+              <a:buChar char="•"/>
+              <a:lnSpc>
+                <a:spcPts val="2200"/>
+              </a:lnSpc>
             </a:pPr>
             <a:r>
               <a:rPr sz="2000" b="0">
                 <a:solidFill>
                   <a:srgbClr val="333333"/>
                 </a:solidFill>
-                <a:latin typeface="Consolas"/>
-              </a:rPr>
-              <a:t>1re fusion A-B                    E-F</a:t>
+                <a:latin typeface="Calibri"/>
+              </a:rPr>
+              <a:t>Enfin, on trie par score décroissant et on départage les égalités par ordre alphabétique</a:t>
             </a:r>
           </a:p>
         </p:txBody>
@@ -5347,50 +5718,28 @@
                 </a:solidFill>
                 <a:latin typeface="Calibri"/>
               </a:rPr>
-              <a:t>Le parcours lab dans le navigateur</a:t>
-            </a:r>
-          </a:p>
-        </p:txBody>
-      </p:sp>
-      <p:pic>
-        <p:nvPicPr>
-          <p:cNvPr id="3" name="Picture 2" descr="lab-starter.png"/>
-          <p:cNvPicPr>
-            <a:picLocks noChangeAspect="1"/>
-          </p:cNvPicPr>
+              <a:t>La deuxième recette en pseudo-code — à essayer</a:t>
+            </a:r>
+          </a:p>
+        </p:txBody>
+      </p:sp>
+      <p:sp>
+        <p:nvSpPr>
+          <p:cNvPr id="3" name="TextBox 2"/>
+          <p:cNvSpPr txBox="1"/>
           <p:nvPr/>
-        </p:nvPicPr>
-        <p:blipFill>
-          <a:blip r:embed="rId2"/>
-          <a:stretch>
-            <a:fillRect/>
-          </a:stretch>
-        </p:blipFill>
+        </p:nvSpPr>
         <p:spPr>
           <a:xfrm>
             <a:off x="548640" y="1143000"/>
-            <a:ext cx="6219507" cy="4571999"/>
+            <a:ext cx="11064240" cy="5029200"/>
           </a:xfrm>
           <a:prstGeom prst="rect">
             <a:avLst/>
           </a:prstGeom>
-        </p:spPr>
-      </p:pic>
-      <p:sp>
-        <p:nvSpPr>
-          <p:cNvPr id="4" name="TextBox 3"/>
-          <p:cNvSpPr txBox="1"/>
-          <p:nvPr/>
-        </p:nvSpPr>
-        <p:spPr>
-          <a:xfrm>
-            <a:off x="548640" y="5897880"/>
-            <a:ext cx="11064240" cy="411480"/>
-          </a:xfrm>
-          <a:prstGeom prst="rect">
-            <a:avLst/>
-          </a:prstGeom>
-          <a:noFill/>
+          <a:solidFill>
+            <a:srgbClr val="F4F4F4"/>
+          </a:solidFill>
         </p:spPr>
         <p:txBody>
           <a:bodyPr wrap="square">
@@ -5402,22 +5751,196 @@
               <a:lnSpc>
                 <a:spcPts val="2200"/>
               </a:lnSpc>
-            </a:pPr>
-            <a:r>
-              <a:rPr sz="1200" b="0">
+              <a:spcAft>
+                <a:spcPts val="400"/>
+              </a:spcAft>
+            </a:pPr>
+            <a:r>
+              <a:rPr sz="2000" b="0">
                 <a:solidFill>
                   <a:srgbClr val="333333"/>
                 </a:solidFill>
-                <a:latin typeface="Calibri"/>
-              </a:rPr>
-              <a:t>Le lab dans le navigateur</a:t>
-            </a:r>
-          </a:p>
-        </p:txBody>
-      </p:sp>
-      <p:sp>
-        <p:nvSpPr>
-          <p:cNvPr id="5" name="TextBox 4"/>
+                <a:latin typeface="Consolas"/>
+              </a:rPr>
+              <a:t>affinity_shared_neighbors(nodes, edges):</a:t>
+            </a:r>
+          </a:p>
+          <a:p>
+            <a:pPr>
+              <a:lnSpc>
+                <a:spcPts val="2200"/>
+              </a:lnSpc>
+              <a:spcAft>
+                <a:spcPts val="400"/>
+              </a:spcAft>
+            </a:pPr>
+            <a:r>
+              <a:rPr sz="2000" b="0">
+                <a:solidFill>
+                  <a:srgbClr val="333333"/>
+                </a:solidFill>
+                <a:latin typeface="Consolas"/>
+              </a:rPr>
+              <a:t>  score[u,v] = w(u,v) pour chaque arête</a:t>
+            </a:r>
+          </a:p>
+          <a:p>
+            <a:pPr>
+              <a:lnSpc>
+                <a:spcPts val="2200"/>
+              </a:lnSpc>
+              <a:spcAft>
+                <a:spcPts val="400"/>
+              </a:spcAft>
+            </a:pPr>
+            <a:r>
+              <a:rPr sz="2000" b="0">
+                <a:solidFill>
+                  <a:srgbClr val="333333"/>
+                </a:solidFill>
+                <a:latin typeface="Consolas"/>
+              </a:rPr>
+              <a:t>  pour chaque paire (u, v) de nœuds :</a:t>
+            </a:r>
+          </a:p>
+          <a:p>
+            <a:pPr>
+              <a:lnSpc>
+                <a:spcPts val="2200"/>
+              </a:lnSpc>
+              <a:spcAft>
+                <a:spcPts val="400"/>
+              </a:spcAft>
+            </a:pPr>
+            <a:r>
+              <a:rPr sz="2000" b="0">
+                <a:solidFill>
+                  <a:srgbClr val="333333"/>
+                </a:solidFill>
+                <a:latin typeface="Consolas"/>
+              </a:rPr>
+              <a:t>    s = 0</a:t>
+            </a:r>
+          </a:p>
+          <a:p>
+            <a:pPr>
+              <a:lnSpc>
+                <a:spcPts val="2200"/>
+              </a:lnSpc>
+              <a:spcAft>
+                <a:spcPts val="400"/>
+              </a:spcAft>
+            </a:pPr>
+            <a:r>
+              <a:rPr sz="2000" b="0">
+                <a:solidFill>
+                  <a:srgbClr val="333333"/>
+                </a:solidFill>
+                <a:latin typeface="Consolas"/>
+              </a:rPr>
+              <a:t>    pour x dans voisins(u), x != v :</a:t>
+            </a:r>
+          </a:p>
+          <a:p>
+            <a:pPr>
+              <a:lnSpc>
+                <a:spcPts val="2200"/>
+              </a:lnSpc>
+              <a:spcAft>
+                <a:spcPts val="400"/>
+              </a:spcAft>
+            </a:pPr>
+            <a:r>
+              <a:rPr sz="2000" b="0">
+                <a:solidFill>
+                  <a:srgbClr val="333333"/>
+                </a:solidFill>
+                <a:latin typeface="Consolas"/>
+              </a:rPr>
+              <a:t>      si x dans voisins(v) :</a:t>
+            </a:r>
+          </a:p>
+          <a:p>
+            <a:pPr>
+              <a:lnSpc>
+                <a:spcPts val="2200"/>
+              </a:lnSpc>
+              <a:spcAft>
+                <a:spcPts val="400"/>
+              </a:spcAft>
+            </a:pPr>
+            <a:r>
+              <a:rPr sz="2000" b="0">
+                <a:solidFill>
+                  <a:srgbClr val="333333"/>
+                </a:solidFill>
+                <a:latin typeface="Consolas"/>
+              </a:rPr>
+              <a:t>        s += min(w(u,x), w(v,x))</a:t>
+            </a:r>
+          </a:p>
+          <a:p>
+            <a:pPr>
+              <a:lnSpc>
+                <a:spcPts val="2200"/>
+              </a:lnSpc>
+              <a:spcAft>
+                <a:spcPts val="400"/>
+              </a:spcAft>
+            </a:pPr>
+            <a:r>
+              <a:rPr sz="2000" b="0">
+                <a:solidFill>
+                  <a:srgbClr val="333333"/>
+                </a:solidFill>
+                <a:latin typeface="Consolas"/>
+              </a:rPr>
+              <a:t>    si s &gt; 0 ou (u,v) a une arête :</a:t>
+            </a:r>
+          </a:p>
+          <a:p>
+            <a:pPr>
+              <a:lnSpc>
+                <a:spcPts val="2200"/>
+              </a:lnSpc>
+              <a:spcAft>
+                <a:spcPts val="400"/>
+              </a:spcAft>
+            </a:pPr>
+            <a:r>
+              <a:rPr sz="2000" b="0">
+                <a:solidFill>
+                  <a:srgbClr val="333333"/>
+                </a:solidFill>
+                <a:latin typeface="Consolas"/>
+              </a:rPr>
+              <a:t>      score[u,v] += s</a:t>
+            </a:r>
+          </a:p>
+          <a:p>
+            <a:pPr>
+              <a:lnSpc>
+                <a:spcPts val="2200"/>
+              </a:lnSpc>
+              <a:spcAft>
+                <a:spcPts val="400"/>
+              </a:spcAft>
+            </a:pPr>
+            <a:r>
+              <a:rPr sz="2000" b="0">
+                <a:solidFill>
+                  <a:srgbClr val="333333"/>
+                </a:solidFill>
+                <a:latin typeface="Consolas"/>
+              </a:rPr>
+              <a:t>  trier par score (décroissant), puis u, puis v</a:t>
+            </a:r>
+          </a:p>
+        </p:txBody>
+      </p:sp>
+      <p:sp>
+        <p:nvSpPr>
+          <p:cNvPr id="4" name="TextBox 3"/>
           <p:cNvSpPr txBox="1"/>
           <p:nvPr/>
         </p:nvSpPr>
@@ -5506,14 +6029,169 @@
                 </a:solidFill>
                 <a:latin typeface="Calibri"/>
               </a:rPr>
-              <a:t>Le parcours implémentation</a:t>
+              <a:t>Même graphe, première fusion différente</a:t>
+            </a:r>
+          </a:p>
+        </p:txBody>
+      </p:sp>
+      <p:sp>
+        <p:nvSpPr>
+          <p:cNvPr id="3" name="TextBox 2"/>
+          <p:cNvSpPr txBox="1"/>
+          <p:nvPr/>
+        </p:nvSpPr>
+        <p:spPr>
+          <a:xfrm>
+            <a:off x="548640" y="1234440"/>
+            <a:ext cx="5303520" cy="4754880"/>
+          </a:xfrm>
+          <a:prstGeom prst="rect">
+            <a:avLst/>
+          </a:prstGeom>
+          <a:noFill/>
+        </p:spPr>
+        <p:txBody>
+          <a:bodyPr wrap="square">
+            <a:noAutofit/>
+          </a:bodyPr>
+          <a:lstStyle/>
+          <a:p>
+            <a:pPr lvl="0" marL="457200" indent="-228600">
+              <a:buFont typeface="Calibri"/>
+              <a:spcAft>
+                <a:spcPts val="1000"/>
+              </a:spcAft>
+              <a:buSzPct val="100000"/>
+              <a:buChar char="•"/>
+              <a:lnSpc>
+                <a:spcPts val="2200"/>
+              </a:lnSpc>
+            </a:pPr>
+            <a:r>
+              <a:rPr sz="2000" b="0">
+                <a:solidFill>
+                  <a:srgbClr val="333333"/>
+                </a:solidFill>
+                <a:latin typeface="Calibri"/>
+              </a:rPr>
+              <a:t>Voici un deuxième exemple qui montre pourquoi la recette compte</a:t>
+            </a:r>
+          </a:p>
+          <a:p>
+            <a:pPr lvl="0" marL="457200" indent="-228600">
+              <a:buFont typeface="Calibri"/>
+              <a:spcAft>
+                <a:spcPts val="1000"/>
+              </a:spcAft>
+              <a:buSzPct val="100000"/>
+              <a:buChar char="•"/>
+              <a:lnSpc>
+                <a:spcPts val="2200"/>
+              </a:lnSpc>
+            </a:pPr>
+            <a:r>
+              <a:rPr sz="2000" b="0">
+                <a:solidFill>
+                  <a:srgbClr val="333333"/>
+                </a:solidFill>
+                <a:latin typeface="Calibri"/>
+              </a:rPr>
+              <a:t>Prenons un triangle serré P, Q, R, dont chaque arête pèse quatre</a:t>
+            </a:r>
+          </a:p>
+          <a:p>
+            <a:pPr lvl="0" marL="457200" indent="-228600">
+              <a:buFont typeface="Calibri"/>
+              <a:spcAft>
+                <a:spcPts val="1000"/>
+              </a:spcAft>
+              <a:buSzPct val="100000"/>
+              <a:buChar char="•"/>
+              <a:lnSpc>
+                <a:spcPts val="2200"/>
+              </a:lnSpc>
+            </a:pPr>
+            <a:r>
+              <a:rPr sz="2000" b="0">
+                <a:solidFill>
+                  <a:srgbClr val="333333"/>
+                </a:solidFill>
+                <a:latin typeface="Calibri"/>
+              </a:rPr>
+              <a:t>À côté, une paire isolée X–Y a un poids de cinq</a:t>
+            </a:r>
+          </a:p>
+          <a:p>
+            <a:pPr lvl="0" marL="457200" indent="-228600">
+              <a:buFont typeface="Calibri"/>
+              <a:spcAft>
+                <a:spcPts val="1000"/>
+              </a:spcAft>
+              <a:buSzPct val="100000"/>
+              <a:buChar char="•"/>
+              <a:lnSpc>
+                <a:spcPts val="2200"/>
+              </a:lnSpc>
+            </a:pPr>
+            <a:r>
+              <a:rPr sz="2000" b="0">
+                <a:solidFill>
+                  <a:srgbClr val="333333"/>
+                </a:solidFill>
+                <a:latin typeface="Calibri"/>
+              </a:rPr>
+              <a:t>La première recette choisit X–Y, car cinq bat quatre</a:t>
+            </a:r>
+          </a:p>
+          <a:p>
+            <a:pPr lvl="0" marL="457200" indent="-228600">
+              <a:buFont typeface="Calibri"/>
+              <a:spcAft>
+                <a:spcPts val="1000"/>
+              </a:spcAft>
+              <a:buSzPct val="100000"/>
+              <a:buChar char="•"/>
+              <a:lnSpc>
+                <a:spcPts val="2200"/>
+              </a:lnSpc>
+            </a:pPr>
+            <a:r>
+              <a:rPr sz="2000" b="0">
+                <a:solidFill>
+                  <a:srgbClr val="333333"/>
+                </a:solidFill>
+                <a:latin typeface="Calibri"/>
+              </a:rPr>
+              <a:t>La deuxième donne à P–Q quatre, plus quatre via R : huit</a:t>
+            </a:r>
+          </a:p>
+          <a:p>
+            <a:pPr lvl="0" marL="457200" indent="-228600">
+              <a:buFont typeface="Calibri"/>
+              <a:spcAft>
+                <a:spcPts val="1000"/>
+              </a:spcAft>
+              <a:buSzPct val="100000"/>
+              <a:buChar char="•"/>
+              <a:lnSpc>
+                <a:spcPts val="2200"/>
+              </a:lnSpc>
+            </a:pPr>
+            <a:r>
+              <a:rPr sz="2000" b="0">
+                <a:solidFill>
+                  <a:srgbClr val="333333"/>
+                </a:solidFill>
+                <a:latin typeface="Calibri"/>
+              </a:rPr>
+              <a:t>P–Q passe donc en premier</a:t>
             </a:r>
           </a:p>
         </p:txBody>
       </p:sp>
       <p:pic>
         <p:nvPicPr>
-          <p:cNvPr id="3" name="Picture 2" descr="real-shell.png"/>
+          <p:cNvPr id="4" name="Picture 3" descr="priority-graph.png"/>
           <p:cNvPicPr>
             <a:picLocks noChangeAspect="1"/>
           </p:cNvPicPr>
@@ -5527,53 +6205,14 @@
         </p:blipFill>
         <p:spPr>
           <a:xfrm>
-            <a:off x="548640" y="1143000"/>
-            <a:ext cx="9160625" cy="4572000"/>
+            <a:off x="6172200" y="1234440"/>
+            <a:ext cx="3548417" cy="4754879"/>
           </a:xfrm>
           <a:prstGeom prst="rect">
             <a:avLst/>
           </a:prstGeom>
         </p:spPr>
       </p:pic>
-      <p:sp>
-        <p:nvSpPr>
-          <p:cNvPr id="4" name="TextBox 3"/>
-          <p:cNvSpPr txBox="1"/>
-          <p:nvPr/>
-        </p:nvSpPr>
-        <p:spPr>
-          <a:xfrm>
-            <a:off x="548640" y="5897880"/>
-            <a:ext cx="11064240" cy="411480"/>
-          </a:xfrm>
-          <a:prstGeom prst="rect">
-            <a:avLst/>
-          </a:prstGeom>
-          <a:noFill/>
-        </p:spPr>
-        <p:txBody>
-          <a:bodyPr wrap="square">
-            <a:noAutofit/>
-          </a:bodyPr>
-          <a:lstStyle/>
-          <a:p>
-            <a:pPr>
-              <a:lnSpc>
-                <a:spcPts val="2200"/>
-              </a:lnSpc>
-            </a:pPr>
-            <a:r>
-              <a:rPr sz="1200" b="0">
-                <a:solidFill>
-                  <a:srgbClr val="333333"/>
-                </a:solidFill>
-                <a:latin typeface="Calibri"/>
-              </a:rPr>
-              <a:t>Session dans un vrai terminal</a:t>
-            </a:r>
-          </a:p>
-        </p:txBody>
-      </p:sp>
       <p:sp>
         <p:nvSpPr>
           <p:cNvPr id="5" name="TextBox 4"/>
@@ -5665,7 +6304,7 @@
                 </a:solidFill>
                 <a:latin typeface="Calibri"/>
               </a:rPr>
-              <a:t>Le parcours implémentation — à essayer</a:t>
+              <a:t>Des nets à nombreuses broches</a:t>
             </a:r>
           </a:p>
         </p:txBody>
@@ -5678,15 +6317,13 @@
         </p:nvSpPr>
         <p:spPr>
           <a:xfrm>
-            <a:off x="548640" y="1143000"/>
-            <a:ext cx="11064240" cy="5029200"/>
+            <a:off x="548640" y="1234440"/>
+            <a:ext cx="5303520" cy="4754880"/>
           </a:xfrm>
           <a:prstGeom prst="rect">
             <a:avLst/>
           </a:prstGeom>
-          <a:solidFill>
-            <a:srgbClr val="F4F4F4"/>
-          </a:solidFill>
+          <a:noFill/>
         </p:spPr>
         <p:txBody>
           <a:bodyPr wrap="square">
@@ -5694,219 +6331,166 @@
           </a:bodyPr>
           <a:lstStyle/>
           <a:p>
-            <a:pPr>
-              <a:lnSpc>
-                <a:spcPts val="2200"/>
-              </a:lnSpc>
+            <a:pPr lvl="0" marL="457200" indent="-228600">
+              <a:buFont typeface="Calibri"/>
               <a:spcAft>
-                <a:spcPts val="400"/>
+                <a:spcPts val="1000"/>
               </a:spcAft>
+              <a:buSzPct val="100000"/>
+              <a:buChar char="•"/>
+              <a:lnSpc>
+                <a:spcPts val="2200"/>
+              </a:lnSpc>
             </a:pPr>
             <a:r>
               <a:rPr sz="2000" b="0">
                 <a:solidFill>
                   <a:srgbClr val="333333"/>
                 </a:solidFill>
-                <a:latin typeface="Consolas"/>
-              </a:rPr>
-              <a:t># indiquer à Python où sont les fonctions partagées</a:t>
-            </a:r>
-          </a:p>
-          <a:p>
-            <a:pPr>
-              <a:lnSpc>
-                <a:spcPts val="2200"/>
-              </a:lnSpc>
+                <a:latin typeface="Calibri"/>
+              </a:rPr>
+              <a:t>Sur une vraie puce, un même fil peut relier plusieurs cellules à la fois</a:t>
+            </a:r>
+          </a:p>
+          <a:p>
+            <a:pPr lvl="0" marL="457200" indent="-228600">
+              <a:buFont typeface="Calibri"/>
               <a:spcAft>
-                <a:spcPts val="400"/>
+                <a:spcPts val="1000"/>
               </a:spcAft>
+              <a:buSzPct val="100000"/>
+              <a:buChar char="•"/>
+              <a:lnSpc>
+                <a:spcPts val="2200"/>
+              </a:lnSpc>
             </a:pPr>
             <a:r>
               <a:rPr sz="2000" b="0">
                 <a:solidFill>
                   <a:srgbClr val="333333"/>
                 </a:solidFill>
-                <a:latin typeface="Consolas"/>
-              </a:rPr>
-              <a:t>export PYTHONPATH=../common</a:t>
-            </a:r>
-          </a:p>
-          <a:p>
-            <a:pPr>
-              <a:lnSpc>
-                <a:spcPts val="2200"/>
-              </a:lnSpc>
+                <a:latin typeface="Calibri"/>
+              </a:rPr>
+              <a:t>Un tel fil partagé s'appelle un net, et chaque cellule qu'il touche est une broche</a:t>
+            </a:r>
+          </a:p>
+          <a:p>
+            <a:pPr lvl="0" marL="457200" indent="-228600">
+              <a:buFont typeface="Calibri"/>
               <a:spcAft>
-                <a:spcPts val="400"/>
+                <a:spcPts val="1000"/>
               </a:spcAft>
+              <a:buSzPct val="100000"/>
+              <a:buChar char="•"/>
+              <a:lnSpc>
+                <a:spcPts val="2200"/>
+              </a:lnSpc>
             </a:pPr>
             <a:r>
               <a:rPr sz="2000" b="0">
                 <a:solidFill>
                   <a:srgbClr val="333333"/>
                 </a:solidFill>
-                <a:latin typeface="Consolas"/>
-              </a:rPr>
-              <a:t/>
-            </a:r>
-          </a:p>
-          <a:p>
-            <a:pPr>
-              <a:lnSpc>
-                <a:spcPts val="2200"/>
-              </a:lnSpc>
+                <a:latin typeface="Calibri"/>
+              </a:rPr>
+              <a:t>Pensez à une discussion de groupe à cinquante : elle en dit peu sur qui est ami avec qui</a:t>
+            </a:r>
+          </a:p>
+          <a:p>
+            <a:pPr lvl="0" marL="457200" indent="-228600">
+              <a:buFont typeface="Calibri"/>
               <a:spcAft>
-                <a:spcPts val="400"/>
+                <a:spcPts val="1000"/>
               </a:spcAft>
+              <a:buSzPct val="100000"/>
+              <a:buChar char="•"/>
+              <a:lnSpc>
+                <a:spcPts val="2200"/>
+              </a:lnSpc>
             </a:pPr>
             <a:r>
               <a:rPr sz="2000" b="0">
                 <a:solidFill>
                   <a:srgbClr val="333333"/>
                 </a:solidFill>
-                <a:latin typeface="Consolas"/>
-              </a:rPr>
-              <a:t># les deux classements : graphe de départ, puis graphe de priorité</a:t>
-            </a:r>
-          </a:p>
-          <a:p>
-            <a:pPr>
-              <a:lnSpc>
-                <a:spcPts val="2200"/>
-              </a:lnSpc>
+                <a:latin typeface="Calibri"/>
+              </a:rPr>
+              <a:t>Un message privé entre deux personnes en dit beaucoup plus</a:t>
+            </a:r>
+          </a:p>
+          <a:p>
+            <a:pPr lvl="0" marL="457200" indent="-228600">
+              <a:buFont typeface="Calibri"/>
               <a:spcAft>
-                <a:spcPts val="400"/>
+                <a:spcPts val="1000"/>
               </a:spcAft>
+              <a:buSzPct val="100000"/>
+              <a:buChar char="•"/>
+              <a:lnSpc>
+                <a:spcPts val="2200"/>
+              </a:lnSpc>
             </a:pPr>
             <a:r>
               <a:rPr sz="2000" b="0">
                 <a:solidFill>
                   <a:srgbClr val="333333"/>
                 </a:solidFill>
-                <a:latin typeface="Consolas"/>
-              </a:rPr>
-              <a:t>python3 ../common/solvers.py examples/tiny_graph.json --mode</a:t>
-            </a:r>
-          </a:p>
-          <a:p>
-            <a:pPr>
-              <a:lnSpc>
-                <a:spcPts val="2200"/>
-              </a:lnSpc>
+                <a:latin typeface="Calibri"/>
+              </a:rPr>
+              <a:t>La troisième recette fonctionne pareil : chaque net partage son poids entre ses broches</a:t>
+            </a:r>
+          </a:p>
+          <a:p>
+            <a:pPr lvl="0" marL="457200" indent="-228600">
+              <a:buFont typeface="Calibri"/>
               <a:spcAft>
-                <a:spcPts val="400"/>
+                <a:spcPts val="1000"/>
               </a:spcAft>
+              <a:buSzPct val="100000"/>
+              <a:buChar char="•"/>
+              <a:lnSpc>
+                <a:spcPts val="2200"/>
+              </a:lnSpc>
             </a:pPr>
             <a:r>
               <a:rPr sz="2000" b="0">
                 <a:solidFill>
                   <a:srgbClr val="333333"/>
                 </a:solidFill>
-                <a:latin typeface="Consolas"/>
-              </a:rPr>
-              <a:t>affinity</a:t>
-            </a:r>
-          </a:p>
-          <a:p>
-            <a:pPr>
-              <a:lnSpc>
-                <a:spcPts val="2200"/>
-              </a:lnSpc>
-              <a:spcAft>
-                <a:spcPts val="400"/>
-              </a:spcAft>
-            </a:pPr>
-            <a:r>
-              <a:rPr sz="2000" b="0">
-                <a:solidFill>
-                  <a:srgbClr val="333333"/>
-                </a:solidFill>
-                <a:latin typeface="Consolas"/>
-              </a:rPr>
-              <a:t>python3 ../common/solvers.py examples/priority_graph.json --mode</a:t>
-            </a:r>
-          </a:p>
-          <a:p>
-            <a:pPr>
-              <a:lnSpc>
-                <a:spcPts val="2200"/>
-              </a:lnSpc>
-              <a:spcAft>
-                <a:spcPts val="400"/>
-              </a:spcAft>
-            </a:pPr>
-            <a:r>
-              <a:rPr sz="2000" b="0">
-                <a:solidFill>
-                  <a:srgbClr val="333333"/>
-                </a:solidFill>
-                <a:latin typeface="Consolas"/>
-              </a:rPr>
-              <a:t>affinity</a:t>
-            </a:r>
-          </a:p>
-          <a:p>
-            <a:pPr>
-              <a:lnSpc>
-                <a:spcPts val="2200"/>
-              </a:lnSpc>
-              <a:spcAft>
-                <a:spcPts val="400"/>
-              </a:spcAft>
-            </a:pPr>
-            <a:r>
-              <a:rPr sz="2000" b="0">
-                <a:solidFill>
-                  <a:srgbClr val="333333"/>
-                </a:solidFill>
-                <a:latin typeface="Consolas"/>
-              </a:rPr>
-              <a:t/>
-            </a:r>
-          </a:p>
-          <a:p>
-            <a:pPr>
-              <a:lnSpc>
-                <a:spcPts val="2200"/>
-              </a:lnSpc>
-              <a:spcAft>
-                <a:spcPts val="400"/>
-              </a:spcAft>
-            </a:pPr>
-            <a:r>
-              <a:rPr sz="2000" b="0">
-                <a:solidFill>
-                  <a:srgbClr val="333333"/>
-                </a:solidFill>
-                <a:latin typeface="Consolas"/>
-              </a:rPr>
-              <a:t># vérifier tous les résultats de référence sur vos propres fonctions</a:t>
-            </a:r>
-          </a:p>
-          <a:p>
-            <a:pPr>
-              <a:lnSpc>
-                <a:spcPts val="2200"/>
-              </a:lnSpc>
-              <a:spcAft>
-                <a:spcPts val="400"/>
-              </a:spcAft>
-            </a:pPr>
-            <a:r>
-              <a:rPr sz="2000" b="0">
-                <a:solidFill>
-                  <a:srgbClr val="333333"/>
-                </a:solidFill>
-                <a:latin typeface="Consolas"/>
-              </a:rPr>
-              <a:t>python3 examples/affinity_check.py --impl my_affinity.py</a:t>
-            </a:r>
-          </a:p>
-        </p:txBody>
-      </p:sp>
-      <p:sp>
-        <p:nvSpPr>
-          <p:cNvPr id="4" name="TextBox 3"/>
+                <a:latin typeface="Calibri"/>
+              </a:rPr>
+              <a:t>La règle : le poids divisé par le nombre de broches moins un</a:t>
+            </a:r>
+          </a:p>
+        </p:txBody>
+      </p:sp>
+      <p:pic>
+        <p:nvPicPr>
+          <p:cNvPr id="4" name="Picture 3" descr="wide-nets.png"/>
+          <p:cNvPicPr>
+            <a:picLocks noChangeAspect="1"/>
+          </p:cNvPicPr>
+          <p:nvPr/>
+        </p:nvPicPr>
+        <p:blipFill>
+          <a:blip r:embed="rId2"/>
+          <a:stretch>
+            <a:fillRect/>
+          </a:stretch>
+        </p:blipFill>
+        <p:spPr>
+          <a:xfrm>
+            <a:off x="6172200" y="1234440"/>
+            <a:ext cx="4256116" cy="4754880"/>
+          </a:xfrm>
+          <a:prstGeom prst="rect">
+            <a:avLst/>
+          </a:prstGeom>
+        </p:spPr>
+      </p:pic>
+      <p:sp>
+        <p:nvSpPr>
+          <p:cNvPr id="5" name="TextBox 4"/>
           <p:cNvSpPr txBox="1"/>
           <p:nvPr/>
         </p:nvSpPr>
@@ -5995,7 +6579,7 @@
                 </a:solidFill>
                 <a:latin typeface="Calibri"/>
               </a:rPr>
-              <a:t>Les pièges à éviter</a:t>
+              <a:t>Des nets à nombreuses broches — à essayer</a:t>
             </a:r>
           </a:p>
         </p:txBody>
@@ -6008,13 +6592,15 @@
         </p:nvSpPr>
         <p:spPr>
           <a:xfrm>
-            <a:off x="548640" y="1234440"/>
-            <a:ext cx="11064240" cy="4937760"/>
+            <a:off x="548640" y="1143000"/>
+            <a:ext cx="11064240" cy="5029200"/>
           </a:xfrm>
           <a:prstGeom prst="rect">
             <a:avLst/>
           </a:prstGeom>
-          <a:noFill/>
+          <a:solidFill>
+            <a:srgbClr val="F4F4F4"/>
+          </a:solidFill>
         </p:spPr>
         <p:txBody>
           <a:bodyPr wrap="square">
@@ -6022,135 +6608,117 @@
           </a:bodyPr>
           <a:lstStyle/>
           <a:p>
-            <a:pPr lvl="0" marL="457200" indent="-228600">
-              <a:buFont typeface="Calibri"/>
+            <a:pPr>
+              <a:lnSpc>
+                <a:spcPts val="2200"/>
+              </a:lnSpc>
               <a:spcAft>
-                <a:spcPts val="1000"/>
+                <a:spcPts val="400"/>
               </a:spcAft>
-              <a:buSzPct val="100000"/>
-              <a:buChar char="•"/>
-              <a:lnSpc>
-                <a:spcPts val="2200"/>
-              </a:lnSpc>
             </a:pPr>
             <a:r>
               <a:rPr sz="2000" b="0">
                 <a:solidFill>
                   <a:srgbClr val="333333"/>
                 </a:solidFill>
-                <a:latin typeface="Calibri"/>
-              </a:rPr>
-              <a:t>Attention à quatre choses</a:t>
-            </a:r>
-          </a:p>
-          <a:p>
-            <a:pPr lvl="0" marL="457200" indent="-228600">
-              <a:buFont typeface="Calibri"/>
+                <a:latin typeface="Consolas"/>
+              </a:rPr>
+              <a:t>petite netlist : en {A,B,C,D,E}, rst {A,B,C,D,E}, n1 {E,F}</a:t>
+            </a:r>
+          </a:p>
+          <a:p>
+            <a:pPr>
+              <a:lnSpc>
+                <a:spcPts val="2200"/>
+              </a:lnSpc>
               <a:spcAft>
-                <a:spcPts val="1000"/>
+                <a:spcPts val="400"/>
               </a:spcAft>
-              <a:buSzPct val="100000"/>
-              <a:buChar char="•"/>
-              <a:lnSpc>
-                <a:spcPts val="2200"/>
-              </a:lnSpc>
             </a:pPr>
             <a:r>
               <a:rPr sz="2000" b="0">
                 <a:solidFill>
                   <a:srgbClr val="333333"/>
                 </a:solidFill>
-                <a:latin typeface="Calibri"/>
-              </a:rPr>
-              <a:t>Compter deux fois une arête non orientée, une fois depuis chaque extrémité</a:t>
-            </a:r>
-          </a:p>
-          <a:p>
-            <a:pPr lvl="0" marL="457200" indent="-228600">
-              <a:buFont typeface="Calibri"/>
+                <a:latin typeface="Consolas"/>
+              </a:rPr>
+              <a:t/>
+            </a:r>
+          </a:p>
+          <a:p>
+            <a:pPr>
+              <a:lnSpc>
+                <a:spcPts val="2200"/>
+              </a:lnSpc>
               <a:spcAft>
-                <a:spcPts val="1000"/>
+                <a:spcPts val="400"/>
               </a:spcAft>
-              <a:buSzPct val="100000"/>
-              <a:buChar char="•"/>
-              <a:lnSpc>
-                <a:spcPts val="2200"/>
-              </a:lnSpc>
             </a:pPr>
             <a:r>
               <a:rPr sz="2000" b="0">
                 <a:solidFill>
                   <a:srgbClr val="333333"/>
                 </a:solidFill>
-                <a:latin typeface="Calibri"/>
-              </a:rPr>
-              <a:t>Ajouter le plus grand rayon au lieu du plus petit, ce qui rend tout proche de tout</a:t>
-            </a:r>
-          </a:p>
-          <a:p>
-            <a:pPr lvl="0" marL="457200" indent="-228600">
-              <a:buFont typeface="Calibri"/>
+                <a:latin typeface="Consolas"/>
+              </a:rPr>
+              <a:t>           nombre brut de nets    nombre de broches w/(|e|-1)</a:t>
+            </a:r>
+          </a:p>
+          <a:p>
+            <a:pPr>
+              <a:lnSpc>
+                <a:spcPts val="2200"/>
+              </a:lnSpc>
               <a:spcAft>
-                <a:spcPts val="1000"/>
+                <a:spcPts val="400"/>
               </a:spcAft>
-              <a:buSzPct val="100000"/>
-              <a:buChar char="•"/>
-              <a:lnSpc>
-                <a:spcPts val="2200"/>
-              </a:lnSpc>
             </a:pPr>
             <a:r>
               <a:rPr sz="2000" b="0">
                 <a:solidFill>
                   <a:srgbClr val="333333"/>
                 </a:solidFill>
-                <a:latin typeface="Calibri"/>
-              </a:rPr>
-              <a:t>Oublier le départage : A–B et D–E changent alors de place d'une exécution à l'autre</a:t>
-            </a:r>
-          </a:p>
-          <a:p>
-            <a:pPr lvl="0" marL="457200" indent="-228600">
-              <a:buFont typeface="Calibri"/>
+                <a:latin typeface="Consolas"/>
+              </a:rPr>
+              <a:t>A-B        1 + 1 = 2              1/4 + 1/4 = 0.5</a:t>
+            </a:r>
+          </a:p>
+          <a:p>
+            <a:pPr>
+              <a:lnSpc>
+                <a:spcPts val="2200"/>
+              </a:lnSpc>
               <a:spcAft>
-                <a:spcPts val="1000"/>
+                <a:spcPts val="400"/>
               </a:spcAft>
-              <a:buSzPct val="100000"/>
-              <a:buChar char="•"/>
-              <a:lnSpc>
-                <a:spcPts val="2200"/>
-              </a:lnSpc>
             </a:pPr>
             <a:r>
               <a:rPr sz="2000" b="0">
                 <a:solidFill>
                   <a:srgbClr val="333333"/>
                 </a:solidFill>
-                <a:latin typeface="Calibri"/>
-              </a:rPr>
-              <a:t>Et compter les nets bruts sur une netlist</a:t>
-            </a:r>
-          </a:p>
-          <a:p>
-            <a:pPr lvl="0" marL="457200" indent="-228600">
-              <a:buFont typeface="Calibri"/>
+                <a:latin typeface="Consolas"/>
+              </a:rPr>
+              <a:t>E-F        1                      1/1 = 1.0</a:t>
+            </a:r>
+          </a:p>
+          <a:p>
+            <a:pPr>
+              <a:lnSpc>
+                <a:spcPts val="2200"/>
+              </a:lnSpc>
               <a:spcAft>
-                <a:spcPts val="1000"/>
+                <a:spcPts val="400"/>
               </a:spcAft>
-              <a:buSzPct val="100000"/>
-              <a:buChar char="•"/>
-              <a:lnSpc>
-                <a:spcPts val="2200"/>
-              </a:lnSpc>
             </a:pPr>
             <a:r>
               <a:rPr sz="2000" b="0">
                 <a:solidFill>
                   <a:srgbClr val="333333"/>
                 </a:solidFill>
-                <a:latin typeface="Calibri"/>
-              </a:rPr>
-              <a:t>Des nets très larges comme le reset collent alors des cellules sans rapport</a:t>
+                <a:latin typeface="Consolas"/>
+              </a:rPr>
+              <a:t>1re fusion A-B                    E-F</a:t>
             </a:r>
           </a:p>
         </p:txBody>
@@ -6246,21 +6814,45 @@
                 </a:solidFill>
                 <a:latin typeface="Calibri"/>
               </a:rPr>
-              <a:t>À vous de jouer</a:t>
-            </a:r>
-          </a:p>
-        </p:txBody>
-      </p:sp>
-      <p:sp>
-        <p:nvSpPr>
-          <p:cNvPr id="3" name="TextBox 2"/>
+              <a:t>Le parcours lab dans le navigateur</a:t>
+            </a:r>
+          </a:p>
+        </p:txBody>
+      </p:sp>
+      <p:pic>
+        <p:nvPicPr>
+          <p:cNvPr id="3" name="Picture 2" descr="lab-starter.png"/>
+          <p:cNvPicPr>
+            <a:picLocks noChangeAspect="1"/>
+          </p:cNvPicPr>
+          <p:nvPr/>
+        </p:nvPicPr>
+        <p:blipFill>
+          <a:blip r:embed="rId2"/>
+          <a:stretch>
+            <a:fillRect/>
+          </a:stretch>
+        </p:blipFill>
+        <p:spPr>
+          <a:xfrm>
+            <a:off x="548640" y="1143000"/>
+            <a:ext cx="6219507" cy="4571999"/>
+          </a:xfrm>
+          <a:prstGeom prst="rect">
+            <a:avLst/>
+          </a:prstGeom>
+        </p:spPr>
+      </p:pic>
+      <p:sp>
+        <p:nvSpPr>
+          <p:cNvPr id="4" name="TextBox 3"/>
           <p:cNvSpPr txBox="1"/>
           <p:nvPr/>
         </p:nvSpPr>
         <p:spPr>
           <a:xfrm>
-            <a:off x="548640" y="1234440"/>
-            <a:ext cx="11064240" cy="4937760"/>
+            <a:off x="548640" y="5897880"/>
+            <a:ext cx="11064240" cy="411480"/>
           </a:xfrm>
           <a:prstGeom prst="rect">
             <a:avLst/>
@@ -6273,113 +6865,508 @@
           </a:bodyPr>
           <a:lstStyle/>
           <a:p>
-            <a:pPr lvl="0" marL="457200" indent="-228600">
-              <a:buFont typeface="Calibri"/>
+            <a:pPr>
+              <a:lnSpc>
+                <a:spcPts val="2200"/>
+              </a:lnSpc>
+            </a:pPr>
+            <a:r>
+              <a:rPr sz="1200" b="0">
+                <a:solidFill>
+                  <a:srgbClr val="333333"/>
+                </a:solidFill>
+                <a:latin typeface="Calibri"/>
+              </a:rPr>
+              <a:t>Le lab dans le navigateur</a:t>
+            </a:r>
+          </a:p>
+        </p:txBody>
+      </p:sp>
+      <p:sp>
+        <p:nvSpPr>
+          <p:cNvPr id="5" name="TextBox 4"/>
+          <p:cNvSpPr txBox="1"/>
+          <p:nvPr/>
+        </p:nvSpPr>
+        <p:spPr>
+          <a:xfrm>
+            <a:off x="548640" y="6355080"/>
+            <a:ext cx="11064240" cy="320040"/>
+          </a:xfrm>
+          <a:prstGeom prst="rect">
+            <a:avLst/>
+          </a:prstGeom>
+          <a:noFill/>
+        </p:spPr>
+        <p:txBody>
+          <a:bodyPr wrap="square">
+            <a:noAutofit/>
+          </a:bodyPr>
+          <a:lstStyle/>
+          <a:p>
+            <a:pPr algn="r">
+              <a:lnSpc>
+                <a:spcPts val="2200"/>
+              </a:lnSpc>
+              <a:defRPr sz="1000" b="0">
+                <a:solidFill>
+                  <a:srgbClr val="666666"/>
+                </a:solidFill>
+                <a:latin typeface="Calibri"/>
+              </a:defRPr>
+            </a:pPr>
+            <a:r>
+              <a:t>learn_clustering — 01 métriques d'affinité</a:t>
+            </a:r>
+          </a:p>
+        </p:txBody>
+      </p:sp>
+    </p:spTree>
+  </p:cSld>
+  <p:clrMapOvr>
+    <a:masterClrMapping/>
+  </p:clrMapOvr>
+</p:sld>
+</file>
+
+<file path=ppt/slides/slide18.xml><?xml version="1.0" encoding="utf-8"?>
+<p:sld xmlns:a="http://schemas.openxmlformats.org/drawingml/2006/main" xmlns:p="http://schemas.openxmlformats.org/presentationml/2006/main" xmlns:r="http://schemas.openxmlformats.org/officeDocument/2006/relationships">
+  <p:cSld>
+    <p:spTree>
+      <p:nvGrpSpPr>
+        <p:cNvPr id="1" name=""/>
+        <p:cNvGrpSpPr/>
+        <p:nvPr/>
+      </p:nvGrpSpPr>
+      <p:grpSpPr/>
+      <p:sp>
+        <p:nvSpPr>
+          <p:cNvPr id="2" name="TextBox 1"/>
+          <p:cNvSpPr txBox="1"/>
+          <p:nvPr/>
+        </p:nvSpPr>
+        <p:spPr>
+          <a:xfrm>
+            <a:off x="548640" y="411480"/>
+            <a:ext cx="11064240" cy="777240"/>
+          </a:xfrm>
+          <a:prstGeom prst="rect">
+            <a:avLst/>
+          </a:prstGeom>
+          <a:noFill/>
+        </p:spPr>
+        <p:txBody>
+          <a:bodyPr wrap="square">
+            <a:noAutofit/>
+          </a:bodyPr>
+          <a:lstStyle/>
+          <a:p>
+            <a:pPr>
+              <a:lnSpc>
+                <a:spcPts val="2200"/>
+              </a:lnSpc>
+            </a:pPr>
+            <a:r>
+              <a:rPr sz="2800" b="1">
+                <a:solidFill>
+                  <a:srgbClr val="1A1A2E"/>
+                </a:solidFill>
+                <a:latin typeface="Calibri"/>
+              </a:rPr>
+              <a:t>Le parcours implémentation</a:t>
+            </a:r>
+          </a:p>
+        </p:txBody>
+      </p:sp>
+      <p:pic>
+        <p:nvPicPr>
+          <p:cNvPr id="3" name="Picture 2" descr="real-shell.png"/>
+          <p:cNvPicPr>
+            <a:picLocks noChangeAspect="1"/>
+          </p:cNvPicPr>
+          <p:nvPr/>
+        </p:nvPicPr>
+        <p:blipFill>
+          <a:blip r:embed="rId2"/>
+          <a:stretch>
+            <a:fillRect/>
+          </a:stretch>
+        </p:blipFill>
+        <p:spPr>
+          <a:xfrm>
+            <a:off x="548640" y="1143000"/>
+            <a:ext cx="9160625" cy="4572000"/>
+          </a:xfrm>
+          <a:prstGeom prst="rect">
+            <a:avLst/>
+          </a:prstGeom>
+        </p:spPr>
+      </p:pic>
+      <p:sp>
+        <p:nvSpPr>
+          <p:cNvPr id="4" name="TextBox 3"/>
+          <p:cNvSpPr txBox="1"/>
+          <p:nvPr/>
+        </p:nvSpPr>
+        <p:spPr>
+          <a:xfrm>
+            <a:off x="548640" y="5897880"/>
+            <a:ext cx="11064240" cy="411480"/>
+          </a:xfrm>
+          <a:prstGeom prst="rect">
+            <a:avLst/>
+          </a:prstGeom>
+          <a:noFill/>
+        </p:spPr>
+        <p:txBody>
+          <a:bodyPr wrap="square">
+            <a:noAutofit/>
+          </a:bodyPr>
+          <a:lstStyle/>
+          <a:p>
+            <a:pPr>
+              <a:lnSpc>
+                <a:spcPts val="2200"/>
+              </a:lnSpc>
+            </a:pPr>
+            <a:r>
+              <a:rPr sz="1200" b="0">
+                <a:solidFill>
+                  <a:srgbClr val="333333"/>
+                </a:solidFill>
+                <a:latin typeface="Calibri"/>
+              </a:rPr>
+              <a:t>Session dans un vrai terminal</a:t>
+            </a:r>
+          </a:p>
+        </p:txBody>
+      </p:sp>
+      <p:sp>
+        <p:nvSpPr>
+          <p:cNvPr id="5" name="TextBox 4"/>
+          <p:cNvSpPr txBox="1"/>
+          <p:nvPr/>
+        </p:nvSpPr>
+        <p:spPr>
+          <a:xfrm>
+            <a:off x="548640" y="6355080"/>
+            <a:ext cx="11064240" cy="320040"/>
+          </a:xfrm>
+          <a:prstGeom prst="rect">
+            <a:avLst/>
+          </a:prstGeom>
+          <a:noFill/>
+        </p:spPr>
+        <p:txBody>
+          <a:bodyPr wrap="square">
+            <a:noAutofit/>
+          </a:bodyPr>
+          <a:lstStyle/>
+          <a:p>
+            <a:pPr algn="r">
+              <a:lnSpc>
+                <a:spcPts val="2200"/>
+              </a:lnSpc>
+              <a:defRPr sz="1000" b="0">
+                <a:solidFill>
+                  <a:srgbClr val="666666"/>
+                </a:solidFill>
+                <a:latin typeface="Calibri"/>
+              </a:defRPr>
+            </a:pPr>
+            <a:r>
+              <a:t>learn_clustering — 01 métriques d'affinité</a:t>
+            </a:r>
+          </a:p>
+        </p:txBody>
+      </p:sp>
+    </p:spTree>
+  </p:cSld>
+  <p:clrMapOvr>
+    <a:masterClrMapping/>
+  </p:clrMapOvr>
+</p:sld>
+</file>
+
+<file path=ppt/slides/slide19.xml><?xml version="1.0" encoding="utf-8"?>
+<p:sld xmlns:a="http://schemas.openxmlformats.org/drawingml/2006/main" xmlns:p="http://schemas.openxmlformats.org/presentationml/2006/main" xmlns:r="http://schemas.openxmlformats.org/officeDocument/2006/relationships">
+  <p:cSld>
+    <p:spTree>
+      <p:nvGrpSpPr>
+        <p:cNvPr id="1" name=""/>
+        <p:cNvGrpSpPr/>
+        <p:nvPr/>
+      </p:nvGrpSpPr>
+      <p:grpSpPr/>
+      <p:sp>
+        <p:nvSpPr>
+          <p:cNvPr id="2" name="TextBox 1"/>
+          <p:cNvSpPr txBox="1"/>
+          <p:nvPr/>
+        </p:nvSpPr>
+        <p:spPr>
+          <a:xfrm>
+            <a:off x="548640" y="411480"/>
+            <a:ext cx="11064240" cy="777240"/>
+          </a:xfrm>
+          <a:prstGeom prst="rect">
+            <a:avLst/>
+          </a:prstGeom>
+          <a:noFill/>
+        </p:spPr>
+        <p:txBody>
+          <a:bodyPr wrap="square">
+            <a:noAutofit/>
+          </a:bodyPr>
+          <a:lstStyle/>
+          <a:p>
+            <a:pPr>
+              <a:lnSpc>
+                <a:spcPts val="2200"/>
+              </a:lnSpc>
+            </a:pPr>
+            <a:r>
+              <a:rPr sz="2800" b="1">
+                <a:solidFill>
+                  <a:srgbClr val="1A1A2E"/>
+                </a:solidFill>
+                <a:latin typeface="Calibri"/>
+              </a:rPr>
+              <a:t>Le parcours implémentation — à essayer</a:t>
+            </a:r>
+          </a:p>
+        </p:txBody>
+      </p:sp>
+      <p:sp>
+        <p:nvSpPr>
+          <p:cNvPr id="3" name="TextBox 2"/>
+          <p:cNvSpPr txBox="1"/>
+          <p:nvPr/>
+        </p:nvSpPr>
+        <p:spPr>
+          <a:xfrm>
+            <a:off x="548640" y="1143000"/>
+            <a:ext cx="11064240" cy="5029200"/>
+          </a:xfrm>
+          <a:prstGeom prst="rect">
+            <a:avLst/>
+          </a:prstGeom>
+          <a:solidFill>
+            <a:srgbClr val="F4F4F4"/>
+          </a:solidFill>
+        </p:spPr>
+        <p:txBody>
+          <a:bodyPr wrap="square">
+            <a:noAutofit/>
+          </a:bodyPr>
+          <a:lstStyle/>
+          <a:p>
+            <a:pPr>
+              <a:lnSpc>
+                <a:spcPts val="2200"/>
+              </a:lnSpc>
               <a:spcAft>
-                <a:spcPts val="1000"/>
+                <a:spcPts val="400"/>
               </a:spcAft>
-              <a:buSzPct val="100000"/>
-              <a:buChar char="•"/>
-              <a:lnSpc>
-                <a:spcPts val="2200"/>
-              </a:lnSpc>
             </a:pPr>
             <a:r>
               <a:rPr sz="2000" b="0">
                 <a:solidFill>
                   <a:srgbClr val="333333"/>
                 </a:solidFill>
-                <a:latin typeface="Calibri"/>
-              </a:rPr>
-              <a:t>Faites passer les trois vérifications de référence</a:t>
-            </a:r>
-          </a:p>
-          <a:p>
-            <a:pPr lvl="0" marL="457200" indent="-228600">
-              <a:buFont typeface="Calibri"/>
+                <a:latin typeface="Consolas"/>
+              </a:rPr>
+              <a:t># indiquer à Python où sont les fonctions partagées</a:t>
+            </a:r>
+          </a:p>
+          <a:p>
+            <a:pPr>
+              <a:lnSpc>
+                <a:spcPts val="2200"/>
+              </a:lnSpc>
               <a:spcAft>
-                <a:spcPts val="1000"/>
+                <a:spcPts val="400"/>
               </a:spcAft>
-              <a:buSzPct val="100000"/>
-              <a:buChar char="•"/>
-              <a:lnSpc>
-                <a:spcPts val="2200"/>
-              </a:lnSpc>
             </a:pPr>
             <a:r>
               <a:rPr sz="2000" b="0">
                 <a:solidFill>
                   <a:srgbClr val="333333"/>
                 </a:solidFill>
-                <a:latin typeface="Calibri"/>
-              </a:rPr>
-              <a:t>Puis expliquez pourquoi A–C monte avec le score par voisins communs</a:t>
-            </a:r>
-          </a:p>
-          <a:p>
-            <a:pPr lvl="0" marL="457200" indent="-228600">
-              <a:buFont typeface="Calibri"/>
+                <a:latin typeface="Consolas"/>
+              </a:rPr>
+              <a:t>export PYTHONPATH=../common</a:t>
+            </a:r>
+          </a:p>
+          <a:p>
+            <a:pPr>
+              <a:lnSpc>
+                <a:spcPts val="2200"/>
+              </a:lnSpc>
               <a:spcAft>
-                <a:spcPts val="1000"/>
+                <a:spcPts val="400"/>
               </a:spcAft>
-              <a:buSzPct val="100000"/>
-              <a:buChar char="•"/>
-              <a:lnSpc>
-                <a:spcPts val="2200"/>
-              </a:lnSpc>
             </a:pPr>
             <a:r>
               <a:rPr sz="2000" b="0">
                 <a:solidFill>
                   <a:srgbClr val="333333"/>
                 </a:solidFill>
-                <a:latin typeface="Calibri"/>
-              </a:rPr>
-              <a:t>Expliquez aussi pourquoi le graphe de priorité change sa première fusion</a:t>
-            </a:r>
-          </a:p>
-          <a:p>
-            <a:pPr lvl="0" marL="457200" indent="-228600">
-              <a:buFont typeface="Calibri"/>
+                <a:latin typeface="Consolas"/>
+              </a:rPr>
+              <a:t/>
+            </a:r>
+          </a:p>
+          <a:p>
+            <a:pPr>
+              <a:lnSpc>
+                <a:spcPts val="2200"/>
+              </a:lnSpc>
               <a:spcAft>
-                <a:spcPts val="1000"/>
+                <a:spcPts val="400"/>
               </a:spcAft>
-              <a:buSzPct val="100000"/>
-              <a:buChar char="•"/>
-              <a:lnSpc>
-                <a:spcPts val="2200"/>
-              </a:lnSpc>
             </a:pPr>
             <a:r>
               <a:rPr sz="2000" b="0">
                 <a:solidFill>
                   <a:srgbClr val="333333"/>
                 </a:solidFill>
-                <a:latin typeface="Calibri"/>
-              </a:rPr>
-              <a:t>Faites le petit quiz</a:t>
-            </a:r>
-          </a:p>
-          <a:p>
-            <a:pPr lvl="0" marL="457200" indent="-228600">
-              <a:buFont typeface="Calibri"/>
+                <a:latin typeface="Consolas"/>
+              </a:rPr>
+              <a:t># les deux classements : graphe de départ, puis graphe de priorité</a:t>
+            </a:r>
+          </a:p>
+          <a:p>
+            <a:pPr>
+              <a:lnSpc>
+                <a:spcPts val="2200"/>
+              </a:lnSpc>
               <a:spcAft>
-                <a:spcPts val="1000"/>
+                <a:spcPts val="400"/>
               </a:spcAft>
-              <a:buSzPct val="100000"/>
-              <a:buChar char="•"/>
-              <a:lnSpc>
-                <a:spcPts val="2200"/>
-              </a:lnSpc>
             </a:pPr>
             <a:r>
               <a:rPr sz="2000" b="0">
                 <a:solidFill>
                   <a:srgbClr val="333333"/>
                 </a:solidFill>
-                <a:latin typeface="Calibri"/>
-              </a:rPr>
-              <a:t>Passez ensuite à la fusion gloutonne par paires, où ces scores deviennent la règle</a:t>
+                <a:latin typeface="Consolas"/>
+              </a:rPr>
+              <a:t>python3 ../common/solvers.py examples/tiny_graph.json --mode</a:t>
+            </a:r>
+          </a:p>
+          <a:p>
+            <a:pPr>
+              <a:lnSpc>
+                <a:spcPts val="2200"/>
+              </a:lnSpc>
+              <a:spcAft>
+                <a:spcPts val="400"/>
+              </a:spcAft>
+            </a:pPr>
+            <a:r>
+              <a:rPr sz="2000" b="0">
+                <a:solidFill>
+                  <a:srgbClr val="333333"/>
+                </a:solidFill>
+                <a:latin typeface="Consolas"/>
+              </a:rPr>
+              <a:t>affinity</a:t>
+            </a:r>
+          </a:p>
+          <a:p>
+            <a:pPr>
+              <a:lnSpc>
+                <a:spcPts val="2200"/>
+              </a:lnSpc>
+              <a:spcAft>
+                <a:spcPts val="400"/>
+              </a:spcAft>
+            </a:pPr>
+            <a:r>
+              <a:rPr sz="2000" b="0">
+                <a:solidFill>
+                  <a:srgbClr val="333333"/>
+                </a:solidFill>
+                <a:latin typeface="Consolas"/>
+              </a:rPr>
+              <a:t>python3 ../common/solvers.py examples/priority_graph.json --mode</a:t>
+            </a:r>
+          </a:p>
+          <a:p>
+            <a:pPr>
+              <a:lnSpc>
+                <a:spcPts val="2200"/>
+              </a:lnSpc>
+              <a:spcAft>
+                <a:spcPts val="400"/>
+              </a:spcAft>
+            </a:pPr>
+            <a:r>
+              <a:rPr sz="2000" b="0">
+                <a:solidFill>
+                  <a:srgbClr val="333333"/>
+                </a:solidFill>
+                <a:latin typeface="Consolas"/>
+              </a:rPr>
+              <a:t>affinity</a:t>
+            </a:r>
+          </a:p>
+          <a:p>
+            <a:pPr>
+              <a:lnSpc>
+                <a:spcPts val="2200"/>
+              </a:lnSpc>
+              <a:spcAft>
+                <a:spcPts val="400"/>
+              </a:spcAft>
+            </a:pPr>
+            <a:r>
+              <a:rPr sz="2000" b="0">
+                <a:solidFill>
+                  <a:srgbClr val="333333"/>
+                </a:solidFill>
+                <a:latin typeface="Consolas"/>
+              </a:rPr>
+              <a:t/>
+            </a:r>
+          </a:p>
+          <a:p>
+            <a:pPr>
+              <a:lnSpc>
+                <a:spcPts val="2200"/>
+              </a:lnSpc>
+              <a:spcAft>
+                <a:spcPts val="400"/>
+              </a:spcAft>
+            </a:pPr>
+            <a:r>
+              <a:rPr sz="2000" b="0">
+                <a:solidFill>
+                  <a:srgbClr val="333333"/>
+                </a:solidFill>
+                <a:latin typeface="Consolas"/>
+              </a:rPr>
+              <a:t># vérifier tous les résultats de référence sur vos propres fonctions</a:t>
+            </a:r>
+          </a:p>
+          <a:p>
+            <a:pPr>
+              <a:lnSpc>
+                <a:spcPts val="2200"/>
+              </a:lnSpc>
+              <a:spcAft>
+                <a:spcPts val="400"/>
+              </a:spcAft>
+            </a:pPr>
+            <a:r>
+              <a:rPr sz="2000" b="0">
+                <a:solidFill>
+                  <a:srgbClr val="333333"/>
+                </a:solidFill>
+                <a:latin typeface="Consolas"/>
+              </a:rPr>
+              <a:t>python3 examples/affinity_check.py --impl my_affinity.py</a:t>
             </a:r>
           </a:p>
         </p:txBody>
@@ -6475,14 +7462,169 @@
                 </a:solidFill>
                 <a:latin typeface="Calibri"/>
               </a:rPr>
-              <a:t>Un petit graphe pondéré</a:t>
+              <a:t>D'une puce à un graphe</a:t>
+            </a:r>
+          </a:p>
+        </p:txBody>
+      </p:sp>
+      <p:sp>
+        <p:nvSpPr>
+          <p:cNvPr id="3" name="TextBox 2"/>
+          <p:cNvSpPr txBox="1"/>
+          <p:nvPr/>
+        </p:nvSpPr>
+        <p:spPr>
+          <a:xfrm>
+            <a:off x="548640" y="1234440"/>
+            <a:ext cx="5303520" cy="4754880"/>
+          </a:xfrm>
+          <a:prstGeom prst="rect">
+            <a:avLst/>
+          </a:prstGeom>
+          <a:noFill/>
+        </p:spPr>
+        <p:txBody>
+          <a:bodyPr wrap="square">
+            <a:noAutofit/>
+          </a:bodyPr>
+          <a:lstStyle/>
+          <a:p>
+            <a:pPr lvl="0" marL="457200" indent="-228600">
+              <a:buFont typeface="Calibri"/>
+              <a:spcAft>
+                <a:spcPts val="1000"/>
+              </a:spcAft>
+              <a:buSzPct val="100000"/>
+              <a:buChar char="•"/>
+              <a:lnSpc>
+                <a:spcPts val="2200"/>
+              </a:lnSpc>
+            </a:pPr>
+            <a:r>
+              <a:rPr sz="2000" b="0">
+                <a:solidFill>
+                  <a:srgbClr val="333333"/>
+                </a:solidFill>
+                <a:latin typeface="Calibri"/>
+              </a:rPr>
+              <a:t>Une puce contient des cellules, les petites briques du circuit</a:t>
+            </a:r>
+          </a:p>
+          <a:p>
+            <a:pPr lvl="0" marL="457200" indent="-228600">
+              <a:buFont typeface="Calibri"/>
+              <a:spcAft>
+                <a:spcPts val="1000"/>
+              </a:spcAft>
+              <a:buSzPct val="100000"/>
+              <a:buChar char="•"/>
+              <a:lnSpc>
+                <a:spcPts val="2200"/>
+              </a:lnSpc>
+            </a:pPr>
+            <a:r>
+              <a:rPr sz="2000" b="0">
+                <a:solidFill>
+                  <a:srgbClr val="333333"/>
+                </a:solidFill>
+                <a:latin typeface="Calibri"/>
+              </a:rPr>
+              <a:t>Les cellules communiquent entre elles par des fils</a:t>
+            </a:r>
+          </a:p>
+          <a:p>
+            <a:pPr lvl="0" marL="457200" indent="-228600">
+              <a:buFont typeface="Calibri"/>
+              <a:spcAft>
+                <a:spcPts val="1000"/>
+              </a:spcAft>
+              <a:buSzPct val="100000"/>
+              <a:buChar char="•"/>
+              <a:lnSpc>
+                <a:spcPts val="2200"/>
+              </a:lnSpc>
+            </a:pPr>
+            <a:r>
+              <a:rPr sz="2000" b="0">
+                <a:solidFill>
+                  <a:srgbClr val="333333"/>
+                </a:solidFill>
+                <a:latin typeface="Calibri"/>
+              </a:rPr>
+              <a:t>On dessine chaque cellule comme un point, appelé nœud</a:t>
+            </a:r>
+          </a:p>
+          <a:p>
+            <a:pPr lvl="0" marL="457200" indent="-228600">
+              <a:buFont typeface="Calibri"/>
+              <a:spcAft>
+                <a:spcPts val="1000"/>
+              </a:spcAft>
+              <a:buSzPct val="100000"/>
+              <a:buChar char="•"/>
+              <a:lnSpc>
+                <a:spcPts val="2200"/>
+              </a:lnSpc>
+            </a:pPr>
+            <a:r>
+              <a:rPr sz="2000" b="0">
+                <a:solidFill>
+                  <a:srgbClr val="333333"/>
+                </a:solidFill>
+                <a:latin typeface="Calibri"/>
+              </a:rPr>
+              <a:t>Un trait entre deux points est une arête : les deux cellules sont reliées</a:t>
+            </a:r>
+          </a:p>
+          <a:p>
+            <a:pPr lvl="0" marL="457200" indent="-228600">
+              <a:buFont typeface="Calibri"/>
+              <a:spcAft>
+                <a:spcPts val="1000"/>
+              </a:spcAft>
+              <a:buSzPct val="100000"/>
+              <a:buChar char="•"/>
+              <a:lnSpc>
+                <a:spcPts val="2200"/>
+              </a:lnSpc>
+            </a:pPr>
+            <a:r>
+              <a:rPr sz="2000" b="0">
+                <a:solidFill>
+                  <a:srgbClr val="333333"/>
+                </a:solidFill>
+                <a:latin typeface="Calibri"/>
+              </a:rPr>
+              <a:t>Le nombre sur une arête est son poids : combien de fils relient la paire</a:t>
+            </a:r>
+          </a:p>
+          <a:p>
+            <a:pPr lvl="0" marL="457200" indent="-228600">
+              <a:buFont typeface="Calibri"/>
+              <a:spcAft>
+                <a:spcPts val="1000"/>
+              </a:spcAft>
+              <a:buSzPct val="100000"/>
+              <a:buChar char="•"/>
+              <a:lnSpc>
+                <a:spcPts val="2200"/>
+              </a:lnSpc>
+            </a:pPr>
+            <a:r>
+              <a:rPr sz="2000" b="0">
+                <a:solidFill>
+                  <a:srgbClr val="333333"/>
+                </a:solidFill>
+                <a:latin typeface="Calibri"/>
+              </a:rPr>
+              <a:t>Ainsi, A–B a un poids de cinq : cinq fils relient A et B</a:t>
             </a:r>
           </a:p>
         </p:txBody>
       </p:sp>
       <p:pic>
         <p:nvPicPr>
-          <p:cNvPr id="3" name="Picture 2" descr="01-raw-graph.png"/>
+          <p:cNvPr id="4" name="Picture 3" descr="chip-to-graph.png"/>
           <p:cNvPicPr>
             <a:picLocks noChangeAspect="1"/>
           </p:cNvPicPr>
@@ -6496,8 +7638,8 @@
         </p:blipFill>
         <p:spPr>
           <a:xfrm>
-            <a:off x="548640" y="1143000"/>
-            <a:ext cx="6746750" cy="4572000"/>
+            <a:off x="6172200" y="1234440"/>
+            <a:ext cx="3823019" cy="4754880"/>
           </a:xfrm>
           <a:prstGeom prst="rect">
             <a:avLst/>
@@ -6506,14 +7648,14 @@
       </p:pic>
       <p:sp>
         <p:nvSpPr>
-          <p:cNvPr id="4" name="TextBox 3"/>
+          <p:cNvPr id="5" name="TextBox 4"/>
           <p:cNvSpPr txBox="1"/>
           <p:nvPr/>
         </p:nvSpPr>
         <p:spPr>
           <a:xfrm>
-            <a:off x="548640" y="5897880"/>
-            <a:ext cx="11064240" cy="411480"/>
+            <a:off x="548640" y="6355080"/>
+            <a:ext cx="11064240" cy="320040"/>
           </a:xfrm>
           <a:prstGeom prst="rect">
             <a:avLst/>
@@ -6526,26 +7668,718 @@
           </a:bodyPr>
           <a:lstStyle/>
           <a:p>
+            <a:pPr algn="r">
+              <a:lnSpc>
+                <a:spcPts val="2200"/>
+              </a:lnSpc>
+              <a:defRPr sz="1000" b="0">
+                <a:solidFill>
+                  <a:srgbClr val="666666"/>
+                </a:solidFill>
+                <a:latin typeface="Calibri"/>
+              </a:defRPr>
+            </a:pPr>
+            <a:r>
+              <a:t>learn_clustering — 01 métriques d'affinité</a:t>
+            </a:r>
+          </a:p>
+        </p:txBody>
+      </p:sp>
+    </p:spTree>
+  </p:cSld>
+  <p:clrMapOvr>
+    <a:masterClrMapping/>
+  </p:clrMapOvr>
+</p:sld>
+</file>
+
+<file path=ppt/slides/slide20.xml><?xml version="1.0" encoding="utf-8"?>
+<p:sld xmlns:a="http://schemas.openxmlformats.org/drawingml/2006/main" xmlns:p="http://schemas.openxmlformats.org/presentationml/2006/main" xmlns:r="http://schemas.openxmlformats.org/officeDocument/2006/relationships">
+  <p:cSld>
+    <p:spTree>
+      <p:nvGrpSpPr>
+        <p:cNvPr id="1" name=""/>
+        <p:cNvGrpSpPr/>
+        <p:nvPr/>
+      </p:nvGrpSpPr>
+      <p:grpSpPr/>
+      <p:sp>
+        <p:nvSpPr>
+          <p:cNvPr id="2" name="TextBox 1"/>
+          <p:cNvSpPr txBox="1"/>
+          <p:nvPr/>
+        </p:nvSpPr>
+        <p:spPr>
+          <a:xfrm>
+            <a:off x="548640" y="411480"/>
+            <a:ext cx="11064240" cy="777240"/>
+          </a:xfrm>
+          <a:prstGeom prst="rect">
+            <a:avLst/>
+          </a:prstGeom>
+          <a:noFill/>
+        </p:spPr>
+        <p:txBody>
+          <a:bodyPr wrap="square">
+            <a:noAutofit/>
+          </a:bodyPr>
+          <a:lstStyle/>
+          <a:p>
             <a:pPr>
               <a:lnSpc>
                 <a:spcPts val="2200"/>
               </a:lnSpc>
             </a:pPr>
             <a:r>
-              <a:rPr sz="1200" b="0">
+              <a:rPr sz="2800" b="1">
+                <a:solidFill>
+                  <a:srgbClr val="1A1A2E"/>
+                </a:solidFill>
+                <a:latin typeface="Calibri"/>
+              </a:rPr>
+              <a:t>Les pièges à éviter</a:t>
+            </a:r>
+          </a:p>
+        </p:txBody>
+      </p:sp>
+      <p:sp>
+        <p:nvSpPr>
+          <p:cNvPr id="3" name="TextBox 2"/>
+          <p:cNvSpPr txBox="1"/>
+          <p:nvPr/>
+        </p:nvSpPr>
+        <p:spPr>
+          <a:xfrm>
+            <a:off x="548640" y="1234440"/>
+            <a:ext cx="11064240" cy="4937760"/>
+          </a:xfrm>
+          <a:prstGeom prst="rect">
+            <a:avLst/>
+          </a:prstGeom>
+          <a:noFill/>
+        </p:spPr>
+        <p:txBody>
+          <a:bodyPr wrap="square">
+            <a:noAutofit/>
+          </a:bodyPr>
+          <a:lstStyle/>
+          <a:p>
+            <a:pPr lvl="0" marL="457200" indent="-228600">
+              <a:buFont typeface="Calibri"/>
+              <a:spcAft>
+                <a:spcPts val="1000"/>
+              </a:spcAft>
+              <a:buSzPct val="100000"/>
+              <a:buChar char="•"/>
+              <a:lnSpc>
+                <a:spcPts val="2200"/>
+              </a:lnSpc>
+            </a:pPr>
+            <a:r>
+              <a:rPr sz="2000" b="0">
                 <a:solidFill>
                   <a:srgbClr val="333333"/>
                 </a:solidFill>
                 <a:latin typeface="Calibri"/>
               </a:rPr>
-              <a:t>Un petit graphe pondéré</a:t>
-            </a:r>
-          </a:p>
-        </p:txBody>
-      </p:sp>
-      <p:sp>
-        <p:nvSpPr>
-          <p:cNvPr id="5" name="TextBox 4"/>
+              <a:t>Attention à quatre erreurs fréquentes</a:t>
+            </a:r>
+          </a:p>
+          <a:p>
+            <a:pPr lvl="0" marL="457200" indent="-228600">
+              <a:buFont typeface="Calibri"/>
+              <a:spcAft>
+                <a:spcPts val="1000"/>
+              </a:spcAft>
+              <a:buSzPct val="100000"/>
+              <a:buChar char="•"/>
+              <a:lnSpc>
+                <a:spcPts val="2200"/>
+              </a:lnSpc>
+            </a:pPr>
+            <a:r>
+              <a:rPr sz="2000" b="0">
+                <a:solidFill>
+                  <a:srgbClr val="333333"/>
+                </a:solidFill>
+                <a:latin typeface="Calibri"/>
+              </a:rPr>
+              <a:t>Compter deux fois une arête, une fois depuis chaque extrémité</a:t>
+            </a:r>
+          </a:p>
+          <a:p>
+            <a:pPr lvl="0" marL="457200" indent="-228600">
+              <a:buFont typeface="Calibri"/>
+              <a:spcAft>
+                <a:spcPts val="1000"/>
+              </a:spcAft>
+              <a:buSzPct val="100000"/>
+              <a:buChar char="•"/>
+              <a:lnSpc>
+                <a:spcPts val="2200"/>
+              </a:lnSpc>
+            </a:pPr>
+            <a:r>
+              <a:rPr sz="2000" b="0">
+                <a:solidFill>
+                  <a:srgbClr val="333333"/>
+                </a:solidFill>
+                <a:latin typeface="Calibri"/>
+              </a:rPr>
+              <a:t>Ajouter le lien le plus fort au lieu du plus faible : tout semble alors proche de tout</a:t>
+            </a:r>
+          </a:p>
+          <a:p>
+            <a:pPr lvl="0" marL="457200" indent="-228600">
+              <a:buFont typeface="Calibri"/>
+              <a:spcAft>
+                <a:spcPts val="1000"/>
+              </a:spcAft>
+              <a:buSzPct val="100000"/>
+              <a:buChar char="•"/>
+              <a:lnSpc>
+                <a:spcPts val="2200"/>
+              </a:lnSpc>
+            </a:pPr>
+            <a:r>
+              <a:rPr sz="2000" b="0">
+                <a:solidFill>
+                  <a:srgbClr val="333333"/>
+                </a:solidFill>
+                <a:latin typeface="Calibri"/>
+              </a:rPr>
+              <a:t>Oublier le départage : A–B et D–E changent de place d'une exécution à l'autre</a:t>
+            </a:r>
+          </a:p>
+          <a:p>
+            <a:pPr lvl="0" marL="457200" indent="-228600">
+              <a:buFont typeface="Calibri"/>
+              <a:spcAft>
+                <a:spcPts val="1000"/>
+              </a:spcAft>
+              <a:buSzPct val="100000"/>
+              <a:buChar char="•"/>
+              <a:lnSpc>
+                <a:spcPts val="2200"/>
+              </a:lnSpc>
+            </a:pPr>
+            <a:r>
+              <a:rPr sz="2000" b="0">
+                <a:solidFill>
+                  <a:srgbClr val="333333"/>
+                </a:solidFill>
+                <a:latin typeface="Calibri"/>
+              </a:rPr>
+              <a:t>Et compter les grands nets partagés à plein poids, ce qui colle des cellules sans rapport</a:t>
+            </a:r>
+          </a:p>
+        </p:txBody>
+      </p:sp>
+      <p:sp>
+        <p:nvSpPr>
+          <p:cNvPr id="4" name="TextBox 3"/>
+          <p:cNvSpPr txBox="1"/>
+          <p:nvPr/>
+        </p:nvSpPr>
+        <p:spPr>
+          <a:xfrm>
+            <a:off x="548640" y="6355080"/>
+            <a:ext cx="11064240" cy="320040"/>
+          </a:xfrm>
+          <a:prstGeom prst="rect">
+            <a:avLst/>
+          </a:prstGeom>
+          <a:noFill/>
+        </p:spPr>
+        <p:txBody>
+          <a:bodyPr wrap="square">
+            <a:noAutofit/>
+          </a:bodyPr>
+          <a:lstStyle/>
+          <a:p>
+            <a:pPr algn="r">
+              <a:lnSpc>
+                <a:spcPts val="2200"/>
+              </a:lnSpc>
+              <a:defRPr sz="1000" b="0">
+                <a:solidFill>
+                  <a:srgbClr val="666666"/>
+                </a:solidFill>
+                <a:latin typeface="Calibri"/>
+              </a:defRPr>
+            </a:pPr>
+            <a:r>
+              <a:t>learn_clustering — 01 métriques d'affinité</a:t>
+            </a:r>
+          </a:p>
+        </p:txBody>
+      </p:sp>
+    </p:spTree>
+  </p:cSld>
+  <p:clrMapOvr>
+    <a:masterClrMapping/>
+  </p:clrMapOvr>
+</p:sld>
+</file>
+
+<file path=ppt/slides/slide21.xml><?xml version="1.0" encoding="utf-8"?>
+<p:sld xmlns:a="http://schemas.openxmlformats.org/drawingml/2006/main" xmlns:p="http://schemas.openxmlformats.org/presentationml/2006/main" xmlns:r="http://schemas.openxmlformats.org/officeDocument/2006/relationships">
+  <p:cSld>
+    <p:spTree>
+      <p:nvGrpSpPr>
+        <p:cNvPr id="1" name=""/>
+        <p:cNvGrpSpPr/>
+        <p:nvPr/>
+      </p:nvGrpSpPr>
+      <p:grpSpPr/>
+      <p:sp>
+        <p:nvSpPr>
+          <p:cNvPr id="2" name="TextBox 1"/>
+          <p:cNvSpPr txBox="1"/>
+          <p:nvPr/>
+        </p:nvSpPr>
+        <p:spPr>
+          <a:xfrm>
+            <a:off x="548640" y="411480"/>
+            <a:ext cx="11064240" cy="777240"/>
+          </a:xfrm>
+          <a:prstGeom prst="rect">
+            <a:avLst/>
+          </a:prstGeom>
+          <a:noFill/>
+        </p:spPr>
+        <p:txBody>
+          <a:bodyPr wrap="square">
+            <a:noAutofit/>
+          </a:bodyPr>
+          <a:lstStyle/>
+          <a:p>
+            <a:pPr>
+              <a:lnSpc>
+                <a:spcPts val="2200"/>
+              </a:lnSpc>
+            </a:pPr>
+            <a:r>
+              <a:rPr sz="2800" b="1">
+                <a:solidFill>
+                  <a:srgbClr val="1A1A2E"/>
+                </a:solidFill>
+                <a:latin typeface="Calibri"/>
+              </a:rPr>
+              <a:t>Récapitulatif : trois recettes</a:t>
+            </a:r>
+          </a:p>
+        </p:txBody>
+      </p:sp>
+      <p:sp>
+        <p:nvSpPr>
+          <p:cNvPr id="3" name="TextBox 2"/>
+          <p:cNvSpPr txBox="1"/>
+          <p:nvPr/>
+        </p:nvSpPr>
+        <p:spPr>
+          <a:xfrm>
+            <a:off x="548640" y="1234440"/>
+            <a:ext cx="11064240" cy="4937760"/>
+          </a:xfrm>
+          <a:prstGeom prst="rect">
+            <a:avLst/>
+          </a:prstGeom>
+          <a:noFill/>
+        </p:spPr>
+        <p:txBody>
+          <a:bodyPr wrap="square">
+            <a:noAutofit/>
+          </a:bodyPr>
+          <a:lstStyle/>
+          <a:p>
+            <a:pPr lvl="0" marL="457200" indent="-228600">
+              <a:buFont typeface="Calibri"/>
+              <a:spcAft>
+                <a:spcPts val="1000"/>
+              </a:spcAft>
+              <a:buSzPct val="100000"/>
+              <a:buChar char="•"/>
+              <a:lnSpc>
+                <a:spcPts val="2200"/>
+              </a:lnSpc>
+            </a:pPr>
+            <a:r>
+              <a:rPr sz="2000" b="0">
+                <a:solidFill>
+                  <a:srgbClr val="333333"/>
+                </a:solidFill>
+                <a:latin typeface="Calibri"/>
+              </a:rPr>
+              <a:t>Recette un, le poids d'arête : on ne regarde que le fil direct</a:t>
+            </a:r>
+          </a:p>
+          <a:p>
+            <a:pPr lvl="0" marL="457200" indent="-228600">
+              <a:buFont typeface="Calibri"/>
+              <a:spcAft>
+                <a:spcPts val="1000"/>
+              </a:spcAft>
+              <a:buSzPct val="100000"/>
+              <a:buChar char="•"/>
+              <a:lnSpc>
+                <a:spcPts val="2200"/>
+              </a:lnSpc>
+            </a:pPr>
+            <a:r>
+              <a:rPr sz="2000" b="0">
+                <a:solidFill>
+                  <a:srgbClr val="333333"/>
+                </a:solidFill>
+                <a:latin typeface="Calibri"/>
+              </a:rPr>
+              <a:t>Recette deux, les voisins communs : on ajoute l'aide des amis communs</a:t>
+            </a:r>
+          </a:p>
+          <a:p>
+            <a:pPr lvl="0" marL="457200" indent="-228600">
+              <a:buFont typeface="Calibri"/>
+              <a:spcAft>
+                <a:spcPts val="1000"/>
+              </a:spcAft>
+              <a:buSzPct val="100000"/>
+              <a:buChar char="•"/>
+              <a:lnSpc>
+                <a:spcPts val="2200"/>
+              </a:lnSpc>
+            </a:pPr>
+            <a:r>
+              <a:rPr sz="2000" b="0">
+                <a:solidFill>
+                  <a:srgbClr val="333333"/>
+                </a:solidFill>
+                <a:latin typeface="Calibri"/>
+              </a:rPr>
+              <a:t>Recette trois, le nombre de broches : un grand net partagé compte moins qu'un net privé</a:t>
+            </a:r>
+          </a:p>
+          <a:p>
+            <a:pPr lvl="0" marL="457200" indent="-228600">
+              <a:buFont typeface="Calibri"/>
+              <a:spcAft>
+                <a:spcPts val="1000"/>
+              </a:spcAft>
+              <a:buSzPct val="100000"/>
+              <a:buChar char="•"/>
+              <a:lnSpc>
+                <a:spcPts val="2200"/>
+              </a:lnSpc>
+            </a:pPr>
+            <a:r>
+              <a:rPr sz="2000" b="0">
+                <a:solidFill>
+                  <a:srgbClr val="333333"/>
+                </a:solidFill>
+                <a:latin typeface="Calibri"/>
+              </a:rPr>
+              <a:t>Les égalités se départagent par ordre alphabétique, donc les résultats ne changent jamais</a:t>
+            </a:r>
+          </a:p>
+          <a:p>
+            <a:pPr lvl="0" marL="457200" indent="-228600">
+              <a:buFont typeface="Calibri"/>
+              <a:spcAft>
+                <a:spcPts val="1000"/>
+              </a:spcAft>
+              <a:buSzPct val="100000"/>
+              <a:buChar char="•"/>
+              <a:lnSpc>
+                <a:spcPts val="2200"/>
+              </a:lnSpc>
+            </a:pPr>
+            <a:r>
+              <a:rPr sz="2000" b="0">
+                <a:solidFill>
+                  <a:srgbClr val="333333"/>
+                </a:solidFill>
+                <a:latin typeface="Calibri"/>
+              </a:rPr>
+              <a:t>Des recettes différentes peuvent choisir une première fusion différente</a:t>
+            </a:r>
+          </a:p>
+          <a:p>
+            <a:pPr lvl="0" marL="457200" indent="-228600">
+              <a:buFont typeface="Calibri"/>
+              <a:spcAft>
+                <a:spcPts val="1000"/>
+              </a:spcAft>
+              <a:buSzPct val="100000"/>
+              <a:buChar char="•"/>
+              <a:lnSpc>
+                <a:spcPts val="2200"/>
+              </a:lnSpc>
+            </a:pPr>
+            <a:r>
+              <a:rPr sz="2000" b="0">
+                <a:solidFill>
+                  <a:srgbClr val="333333"/>
+                </a:solidFill>
+                <a:latin typeface="Calibri"/>
+              </a:rPr>
+              <a:t>Choisir la recette est une décision de conception, pas un détail</a:t>
+            </a:r>
+          </a:p>
+        </p:txBody>
+      </p:sp>
+      <p:sp>
+        <p:nvSpPr>
+          <p:cNvPr id="4" name="TextBox 3"/>
+          <p:cNvSpPr txBox="1"/>
+          <p:nvPr/>
+        </p:nvSpPr>
+        <p:spPr>
+          <a:xfrm>
+            <a:off x="548640" y="6355080"/>
+            <a:ext cx="11064240" cy="320040"/>
+          </a:xfrm>
+          <a:prstGeom prst="rect">
+            <a:avLst/>
+          </a:prstGeom>
+          <a:noFill/>
+        </p:spPr>
+        <p:txBody>
+          <a:bodyPr wrap="square">
+            <a:noAutofit/>
+          </a:bodyPr>
+          <a:lstStyle/>
+          <a:p>
+            <a:pPr algn="r">
+              <a:lnSpc>
+                <a:spcPts val="2200"/>
+              </a:lnSpc>
+              <a:defRPr sz="1000" b="0">
+                <a:solidFill>
+                  <a:srgbClr val="666666"/>
+                </a:solidFill>
+                <a:latin typeface="Calibri"/>
+              </a:defRPr>
+            </a:pPr>
+            <a:r>
+              <a:t>learn_clustering — 01 métriques d'affinité</a:t>
+            </a:r>
+          </a:p>
+        </p:txBody>
+      </p:sp>
+    </p:spTree>
+  </p:cSld>
+  <p:clrMapOvr>
+    <a:masterClrMapping/>
+  </p:clrMapOvr>
+</p:sld>
+</file>
+
+<file path=ppt/slides/slide22.xml><?xml version="1.0" encoding="utf-8"?>
+<p:sld xmlns:a="http://schemas.openxmlformats.org/drawingml/2006/main" xmlns:p="http://schemas.openxmlformats.org/presentationml/2006/main" xmlns:r="http://schemas.openxmlformats.org/officeDocument/2006/relationships">
+  <p:cSld>
+    <p:spTree>
+      <p:nvGrpSpPr>
+        <p:cNvPr id="1" name=""/>
+        <p:cNvGrpSpPr/>
+        <p:nvPr/>
+      </p:nvGrpSpPr>
+      <p:grpSpPr/>
+      <p:sp>
+        <p:nvSpPr>
+          <p:cNvPr id="2" name="TextBox 1"/>
+          <p:cNvSpPr txBox="1"/>
+          <p:nvPr/>
+        </p:nvSpPr>
+        <p:spPr>
+          <a:xfrm>
+            <a:off x="548640" y="411480"/>
+            <a:ext cx="11064240" cy="777240"/>
+          </a:xfrm>
+          <a:prstGeom prst="rect">
+            <a:avLst/>
+          </a:prstGeom>
+          <a:noFill/>
+        </p:spPr>
+        <p:txBody>
+          <a:bodyPr wrap="square">
+            <a:noAutofit/>
+          </a:bodyPr>
+          <a:lstStyle/>
+          <a:p>
+            <a:pPr>
+              <a:lnSpc>
+                <a:spcPts val="2200"/>
+              </a:lnSpc>
+            </a:pPr>
+            <a:r>
+              <a:rPr sz="2800" b="1">
+                <a:solidFill>
+                  <a:srgbClr val="1A1A2E"/>
+                </a:solidFill>
+                <a:latin typeface="Calibri"/>
+              </a:rPr>
+              <a:t>À vous de jouer</a:t>
+            </a:r>
+          </a:p>
+        </p:txBody>
+      </p:sp>
+      <p:sp>
+        <p:nvSpPr>
+          <p:cNvPr id="3" name="TextBox 2"/>
+          <p:cNvSpPr txBox="1"/>
+          <p:nvPr/>
+        </p:nvSpPr>
+        <p:spPr>
+          <a:xfrm>
+            <a:off x="548640" y="1234440"/>
+            <a:ext cx="11064240" cy="4937760"/>
+          </a:xfrm>
+          <a:prstGeom prst="rect">
+            <a:avLst/>
+          </a:prstGeom>
+          <a:noFill/>
+        </p:spPr>
+        <p:txBody>
+          <a:bodyPr wrap="square">
+            <a:noAutofit/>
+          </a:bodyPr>
+          <a:lstStyle/>
+          <a:p>
+            <a:pPr lvl="0" marL="457200" indent="-228600">
+              <a:buFont typeface="Calibri"/>
+              <a:spcAft>
+                <a:spcPts val="1000"/>
+              </a:spcAft>
+              <a:buSzPct val="100000"/>
+              <a:buChar char="•"/>
+              <a:lnSpc>
+                <a:spcPts val="2200"/>
+              </a:lnSpc>
+            </a:pPr>
+            <a:r>
+              <a:rPr sz="2000" b="0">
+                <a:solidFill>
+                  <a:srgbClr val="333333"/>
+                </a:solidFill>
+                <a:latin typeface="Calibri"/>
+              </a:rPr>
+              <a:t>Essayez les défis du lab, ou écrivez les trois recettes et passez le vérificateur</a:t>
+            </a:r>
+          </a:p>
+          <a:p>
+            <a:pPr lvl="0" marL="457200" indent="-228600">
+              <a:buFont typeface="Calibri"/>
+              <a:spcAft>
+                <a:spcPts val="1000"/>
+              </a:spcAft>
+              <a:buSzPct val="100000"/>
+              <a:buChar char="•"/>
+              <a:lnSpc>
+                <a:spcPts val="2200"/>
+              </a:lnSpc>
+            </a:pPr>
+            <a:r>
+              <a:rPr sz="2000" b="0">
+                <a:solidFill>
+                  <a:srgbClr val="333333"/>
+                </a:solidFill>
+                <a:latin typeface="Calibri"/>
+              </a:rPr>
+              <a:t>Puis expliquez deux choses avec vos propres mots</a:t>
+            </a:r>
+          </a:p>
+          <a:p>
+            <a:pPr lvl="0" marL="457200" indent="-228600">
+              <a:buFont typeface="Calibri"/>
+              <a:spcAft>
+                <a:spcPts val="1000"/>
+              </a:spcAft>
+              <a:buSzPct val="100000"/>
+              <a:buChar char="•"/>
+              <a:lnSpc>
+                <a:spcPts val="2200"/>
+              </a:lnSpc>
+            </a:pPr>
+            <a:r>
+              <a:rPr sz="2000" b="0">
+                <a:solidFill>
+                  <a:srgbClr val="333333"/>
+                </a:solidFill>
+                <a:latin typeface="Calibri"/>
+              </a:rPr>
+              <a:t>D'abord, pourquoi A–C monte-t-elle avec la deuxième recette ?</a:t>
+            </a:r>
+          </a:p>
+          <a:p>
+            <a:pPr lvl="0" marL="457200" indent="-228600">
+              <a:buFont typeface="Calibri"/>
+              <a:spcAft>
+                <a:spcPts val="1000"/>
+              </a:spcAft>
+              <a:buSzPct val="100000"/>
+              <a:buChar char="•"/>
+              <a:lnSpc>
+                <a:spcPts val="2200"/>
+              </a:lnSpc>
+            </a:pPr>
+            <a:r>
+              <a:rPr sz="2000" b="0">
+                <a:solidFill>
+                  <a:srgbClr val="333333"/>
+                </a:solidFill>
+                <a:latin typeface="Calibri"/>
+              </a:rPr>
+              <a:t>Ensuite, pourquoi le graphe de priorité change-t-il sa première fusion ?</a:t>
+            </a:r>
+          </a:p>
+          <a:p>
+            <a:pPr lvl="0" marL="457200" indent="-228600">
+              <a:buFont typeface="Calibri"/>
+              <a:spcAft>
+                <a:spcPts val="1000"/>
+              </a:spcAft>
+              <a:buSzPct val="100000"/>
+              <a:buChar char="•"/>
+              <a:lnSpc>
+                <a:spcPts val="2200"/>
+              </a:lnSpc>
+            </a:pPr>
+            <a:r>
+              <a:rPr sz="2000" b="0">
+                <a:solidFill>
+                  <a:srgbClr val="333333"/>
+                </a:solidFill>
+                <a:latin typeface="Calibri"/>
+              </a:rPr>
+              <a:t>Faites le petit quiz, puis passez à la fusion gloutonne par paires</a:t>
+            </a:r>
+          </a:p>
+          <a:p>
+            <a:pPr lvl="0" marL="457200" indent="-228600">
+              <a:buFont typeface="Calibri"/>
+              <a:spcAft>
+                <a:spcPts val="1000"/>
+              </a:spcAft>
+              <a:buSzPct val="100000"/>
+              <a:buChar char="•"/>
+              <a:lnSpc>
+                <a:spcPts val="2200"/>
+              </a:lnSpc>
+            </a:pPr>
+            <a:r>
+              <a:rPr sz="2000" b="0">
+                <a:solidFill>
+                  <a:srgbClr val="333333"/>
+                </a:solidFill>
+                <a:latin typeface="Calibri"/>
+              </a:rPr>
+              <a:t>Là, ces scores deviennent la règle de fusion</a:t>
+            </a:r>
+          </a:p>
+        </p:txBody>
+      </p:sp>
+      <p:sp>
+        <p:nvSpPr>
+          <p:cNvPr id="4" name="TextBox 3"/>
           <p:cNvSpPr txBox="1"/>
           <p:nvPr/>
         </p:nvSpPr>
@@ -6634,14 +8468,169 @@
                 </a:solidFill>
                 <a:latin typeface="Calibri"/>
               </a:rPr>
-              <a:t>L'affinité par poids d'arête classe les paires</a:t>
+              <a:t>Pourquoi regrouper les cellules ?</a:t>
+            </a:r>
+          </a:p>
+        </p:txBody>
+      </p:sp>
+      <p:sp>
+        <p:nvSpPr>
+          <p:cNvPr id="3" name="TextBox 2"/>
+          <p:cNvSpPr txBox="1"/>
+          <p:nvPr/>
+        </p:nvSpPr>
+        <p:spPr>
+          <a:xfrm>
+            <a:off x="548640" y="1234440"/>
+            <a:ext cx="5303520" cy="4754880"/>
+          </a:xfrm>
+          <a:prstGeom prst="rect">
+            <a:avLst/>
+          </a:prstGeom>
+          <a:noFill/>
+        </p:spPr>
+        <p:txBody>
+          <a:bodyPr wrap="square">
+            <a:noAutofit/>
+          </a:bodyPr>
+          <a:lstStyle/>
+          <a:p>
+            <a:pPr lvl="0" marL="457200" indent="-228600">
+              <a:buFont typeface="Calibri"/>
+              <a:spcAft>
+                <a:spcPts val="1000"/>
+              </a:spcAft>
+              <a:buSzPct val="100000"/>
+              <a:buChar char="•"/>
+              <a:lnSpc>
+                <a:spcPts val="2200"/>
+              </a:lnSpc>
+            </a:pPr>
+            <a:r>
+              <a:rPr sz="2000" b="0">
+                <a:solidFill>
+                  <a:srgbClr val="333333"/>
+                </a:solidFill>
+                <a:latin typeface="Calibri"/>
+              </a:rPr>
+              <a:t>Les cellules qui échangent beaucoup de signaux doivent être proches</a:t>
+            </a:r>
+          </a:p>
+          <a:p>
+            <a:pPr lvl="0" marL="457200" indent="-228600">
+              <a:buFont typeface="Calibri"/>
+              <a:spcAft>
+                <a:spcPts val="1000"/>
+              </a:spcAft>
+              <a:buSzPct val="100000"/>
+              <a:buChar char="•"/>
+              <a:lnSpc>
+                <a:spcPts val="2200"/>
+              </a:lnSpc>
+            </a:pPr>
+            <a:r>
+              <a:rPr sz="2000" b="0">
+                <a:solidFill>
+                  <a:srgbClr val="333333"/>
+                </a:solidFill>
+                <a:latin typeface="Calibri"/>
+              </a:rPr>
+              <a:t>Des fils courts rendent la puce plus rapide et économisent de l'énergie</a:t>
+            </a:r>
+          </a:p>
+          <a:p>
+            <a:pPr lvl="0" marL="457200" indent="-228600">
+              <a:buFont typeface="Calibri"/>
+              <a:spcAft>
+                <a:spcPts val="1000"/>
+              </a:spcAft>
+              <a:buSzPct val="100000"/>
+              <a:buChar char="•"/>
+              <a:lnSpc>
+                <a:spcPts val="2200"/>
+              </a:lnSpc>
+            </a:pPr>
+            <a:r>
+              <a:rPr sz="2000" b="0">
+                <a:solidFill>
+                  <a:srgbClr val="333333"/>
+                </a:solidFill>
+                <a:latin typeface="Calibri"/>
+              </a:rPr>
+              <a:t>Regrouper les cellules proches s'appelle le clustering, et chaque groupe est un cluster</a:t>
+            </a:r>
+          </a:p>
+          <a:p>
+            <a:pPr lvl="0" marL="457200" indent="-228600">
+              <a:buFont typeface="Calibri"/>
+              <a:spcAft>
+                <a:spcPts val="1000"/>
+              </a:spcAft>
+              <a:buSzPct val="100000"/>
+              <a:buChar char="•"/>
+              <a:lnSpc>
+                <a:spcPts val="2200"/>
+              </a:lnSpc>
+            </a:pPr>
+            <a:r>
+              <a:rPr sz="2000" b="0">
+                <a:solidFill>
+                  <a:srgbClr val="333333"/>
+                </a:solidFill>
+                <a:latin typeface="Calibri"/>
+              </a:rPr>
+              <a:t>Pensez à un plan de classe : les amis qui discutent beaucoup s'assoient ensemble</a:t>
+            </a:r>
+          </a:p>
+          <a:p>
+            <a:pPr lvl="0" marL="457200" indent="-228600">
+              <a:buFont typeface="Calibri"/>
+              <a:spcAft>
+                <a:spcPts val="1000"/>
+              </a:spcAft>
+              <a:buSzPct val="100000"/>
+              <a:buChar char="•"/>
+              <a:lnSpc>
+                <a:spcPts val="2200"/>
+              </a:lnSpc>
+            </a:pPr>
+            <a:r>
+              <a:rPr sz="2000" b="0">
+                <a:solidFill>
+                  <a:srgbClr val="333333"/>
+                </a:solidFill>
+                <a:latin typeface="Calibri"/>
+              </a:rPr>
+              <a:t>Ici, A, B et C forment un groupe, et D et E en forment un autre</a:t>
+            </a:r>
+          </a:p>
+          <a:p>
+            <a:pPr lvl="0" marL="457200" indent="-228600">
+              <a:buFont typeface="Calibri"/>
+              <a:spcAft>
+                <a:spcPts val="1000"/>
+              </a:spcAft>
+              <a:buSzPct val="100000"/>
+              <a:buChar char="•"/>
+              <a:lnSpc>
+                <a:spcPts val="2200"/>
+              </a:lnSpc>
+            </a:pPr>
+            <a:r>
+              <a:rPr sz="2000" b="0">
+                <a:solidFill>
+                  <a:srgbClr val="333333"/>
+                </a:solidFill>
+                <a:latin typeface="Calibri"/>
+              </a:rPr>
+              <a:t>Seules les arêtes rouges passent d'un groupe à l'autre, et on en veut le moins possible</a:t>
             </a:r>
           </a:p>
         </p:txBody>
       </p:sp>
       <p:pic>
         <p:nvPicPr>
-          <p:cNvPr id="3" name="Picture 2" descr="02-edge-rank.png"/>
+          <p:cNvPr id="4" name="Picture 3" descr="clustering-groups.png"/>
           <p:cNvPicPr>
             <a:picLocks noChangeAspect="1"/>
           </p:cNvPicPr>
@@ -6655,53 +8644,14 @@
         </p:blipFill>
         <p:spPr>
           <a:xfrm>
-            <a:off x="548640" y="1143000"/>
-            <a:ext cx="6746750" cy="4572000"/>
+            <a:off x="6172200" y="1470755"/>
+            <a:ext cx="5394960" cy="4282250"/>
           </a:xfrm>
           <a:prstGeom prst="rect">
             <a:avLst/>
           </a:prstGeom>
         </p:spPr>
       </p:pic>
-      <p:sp>
-        <p:nvSpPr>
-          <p:cNvPr id="4" name="TextBox 3"/>
-          <p:cNvSpPr txBox="1"/>
-          <p:nvPr/>
-        </p:nvSpPr>
-        <p:spPr>
-          <a:xfrm>
-            <a:off x="548640" y="5897880"/>
-            <a:ext cx="11064240" cy="411480"/>
-          </a:xfrm>
-          <a:prstGeom prst="rect">
-            <a:avLst/>
-          </a:prstGeom>
-          <a:noFill/>
-        </p:spPr>
-        <p:txBody>
-          <a:bodyPr wrap="square">
-            <a:noAutofit/>
-          </a:bodyPr>
-          <a:lstStyle/>
-          <a:p>
-            <a:pPr>
-              <a:lnSpc>
-                <a:spcPts val="2200"/>
-              </a:lnSpc>
-            </a:pPr>
-            <a:r>
-              <a:rPr sz="1200" b="0">
-                <a:solidFill>
-                  <a:srgbClr val="333333"/>
-                </a:solidFill>
-                <a:latin typeface="Calibri"/>
-              </a:rPr>
-              <a:t>L'affinité par poids d'arête classe les paires</a:t>
-            </a:r>
-          </a:p>
-        </p:txBody>
-      </p:sp>
       <p:sp>
         <p:nvSpPr>
           <p:cNvPr id="5" name="TextBox 4"/>
@@ -6793,45 +8743,21 @@
                 </a:solidFill>
                 <a:latin typeface="Calibri"/>
               </a:rPr>
-              <a:t>Les voisins communs renforcent A–B</a:t>
-            </a:r>
-          </a:p>
-        </p:txBody>
-      </p:sp>
-      <p:pic>
-        <p:nvPicPr>
-          <p:cNvPr id="3" name="Picture 2" descr="03-shared-idea.png"/>
-          <p:cNvPicPr>
-            <a:picLocks noChangeAspect="1"/>
-          </p:cNvPicPr>
-          <p:nvPr/>
-        </p:nvPicPr>
-        <p:blipFill>
-          <a:blip r:embed="rId2"/>
-          <a:stretch>
-            <a:fillRect/>
-          </a:stretch>
-        </p:blipFill>
-        <p:spPr>
-          <a:xfrm>
-            <a:off x="548640" y="1143000"/>
-            <a:ext cx="6746750" cy="4572000"/>
-          </a:xfrm>
-          <a:prstGeom prst="rect">
-            <a:avLst/>
-          </a:prstGeom>
-        </p:spPr>
-      </p:pic>
-      <p:sp>
-        <p:nvSpPr>
-          <p:cNvPr id="4" name="TextBox 3"/>
+              <a:t>Qu'est-ce que l'affinité ?</a:t>
+            </a:r>
+          </a:p>
+        </p:txBody>
+      </p:sp>
+      <p:sp>
+        <p:nvSpPr>
+          <p:cNvPr id="3" name="TextBox 2"/>
           <p:cNvSpPr txBox="1"/>
           <p:nvPr/>
         </p:nvSpPr>
         <p:spPr>
           <a:xfrm>
-            <a:off x="548640" y="5897880"/>
-            <a:ext cx="11064240" cy="411480"/>
+            <a:off x="548640" y="1234440"/>
+            <a:ext cx="11064240" cy="4937760"/>
           </a:xfrm>
           <a:prstGeom prst="rect">
             <a:avLst/>
@@ -6844,26 +8770,142 @@
           </a:bodyPr>
           <a:lstStyle/>
           <a:p>
-            <a:pPr>
-              <a:lnSpc>
-                <a:spcPts val="2200"/>
-              </a:lnSpc>
-            </a:pPr>
-            <a:r>
-              <a:rPr sz="1200" b="0">
+            <a:pPr lvl="0" marL="457200" indent="-228600">
+              <a:buFont typeface="Calibri"/>
+              <a:spcAft>
+                <a:spcPts val="1000"/>
+              </a:spcAft>
+              <a:buSzPct val="100000"/>
+              <a:buChar char="•"/>
+              <a:lnSpc>
+                <a:spcPts val="2200"/>
+              </a:lnSpc>
+            </a:pPr>
+            <a:r>
+              <a:rPr sz="2000" b="0">
                 <a:solidFill>
                   <a:srgbClr val="333333"/>
                 </a:solidFill>
                 <a:latin typeface="Calibri"/>
               </a:rPr>
-              <a:t>Les voisins communs renforcent A–B</a:t>
-            </a:r>
-          </a:p>
-        </p:txBody>
-      </p:sp>
-      <p:sp>
-        <p:nvSpPr>
-          <p:cNvPr id="5" name="TextBox 4"/>
+              <a:t>L'affinité est un score donné à chaque paire de cellules</a:t>
+            </a:r>
+          </a:p>
+          <a:p>
+            <a:pPr lvl="0" marL="457200" indent="-228600">
+              <a:buFont typeface="Calibri"/>
+              <a:spcAft>
+                <a:spcPts val="1000"/>
+              </a:spcAft>
+              <a:buSzPct val="100000"/>
+              <a:buChar char="•"/>
+              <a:lnSpc>
+                <a:spcPts val="2200"/>
+              </a:lnSpc>
+            </a:pPr>
+            <a:r>
+              <a:rPr sz="2000" b="0">
+                <a:solidFill>
+                  <a:srgbClr val="333333"/>
+                </a:solidFill>
+                <a:latin typeface="Calibri"/>
+              </a:rPr>
+              <a:t>Un score élevé veut dire que ces deux-là doivent être dans le même groupe</a:t>
+            </a:r>
+          </a:p>
+          <a:p>
+            <a:pPr lvl="0" marL="457200" indent="-228600">
+              <a:buFont typeface="Calibri"/>
+              <a:spcAft>
+                <a:spcPts val="1000"/>
+              </a:spcAft>
+              <a:buSzPct val="100000"/>
+              <a:buChar char="•"/>
+              <a:lnSpc>
+                <a:spcPts val="2200"/>
+              </a:lnSpc>
+            </a:pPr>
+            <a:r>
+              <a:rPr sz="2000" b="0">
+                <a:solidFill>
+                  <a:srgbClr val="333333"/>
+                </a:solidFill>
+                <a:latin typeface="Calibri"/>
+              </a:rPr>
+              <a:t>Un score faible veut dire qu'elles peuvent être séparées</a:t>
+            </a:r>
+          </a:p>
+          <a:p>
+            <a:pPr lvl="0" marL="457200" indent="-228600">
+              <a:buFont typeface="Calibri"/>
+              <a:spcAft>
+                <a:spcPts val="1000"/>
+              </a:spcAft>
+              <a:buSzPct val="100000"/>
+              <a:buChar char="•"/>
+              <a:lnSpc>
+                <a:spcPts val="2200"/>
+              </a:lnSpc>
+            </a:pPr>
+            <a:r>
+              <a:rPr sz="2000" b="0">
+                <a:solidFill>
+                  <a:srgbClr val="333333"/>
+                </a:solidFill>
+                <a:latin typeface="Calibri"/>
+              </a:rPr>
+              <a:t>Les algorithmes de clustering fusionnent d'abord la paire qui a le meilleur score</a:t>
+            </a:r>
+          </a:p>
+          <a:p>
+            <a:pPr lvl="0" marL="457200" indent="-228600">
+              <a:buFont typeface="Calibri"/>
+              <a:spcAft>
+                <a:spcPts val="1000"/>
+              </a:spcAft>
+              <a:buSzPct val="100000"/>
+              <a:buChar char="•"/>
+              <a:lnSpc>
+                <a:spcPts val="2200"/>
+              </a:lnSpc>
+            </a:pPr>
+            <a:r>
+              <a:rPr sz="2000" b="0">
+                <a:solidFill>
+                  <a:srgbClr val="333333"/>
+                </a:solidFill>
+                <a:latin typeface="Calibri"/>
+              </a:rPr>
+              <a:t>La recette du score décide donc de tout ce qui suit</a:t>
+            </a:r>
+          </a:p>
+          <a:p>
+            <a:pPr lvl="0" marL="457200" indent="-228600">
+              <a:buFont typeface="Calibri"/>
+              <a:spcAft>
+                <a:spcPts val="1000"/>
+              </a:spcAft>
+              <a:buSzPct val="100000"/>
+              <a:buChar char="•"/>
+              <a:lnSpc>
+                <a:spcPts val="2200"/>
+              </a:lnSpc>
+            </a:pPr>
+            <a:r>
+              <a:rPr sz="2000" b="0">
+                <a:solidFill>
+                  <a:srgbClr val="333333"/>
+                </a:solidFill>
+                <a:latin typeface="Calibri"/>
+              </a:rPr>
+              <a:t>Ce lab compare trois recettes sur le même petit exemple</a:t>
+            </a:r>
+          </a:p>
+        </p:txBody>
+      </p:sp>
+      <p:sp>
+        <p:nvSpPr>
+          <p:cNvPr id="4" name="TextBox 3"/>
           <p:cNvSpPr txBox="1"/>
           <p:nvPr/>
         </p:nvSpPr>
@@ -6952,14 +8994,14 @@
                 </a:solidFill>
                 <a:latin typeface="Calibri"/>
               </a:rPr>
-              <a:t>Le classement par voisins communs rebat les cartes</a:t>
+              <a:t>Un petit graphe pondéré</a:t>
             </a:r>
           </a:p>
         </p:txBody>
       </p:sp>
       <p:pic>
         <p:nvPicPr>
-          <p:cNvPr id="3" name="Picture 2" descr="04-shared-rank.png"/>
+          <p:cNvPr id="3" name="Picture 2" descr="01-raw-graph.png"/>
           <p:cNvPicPr>
             <a:picLocks noChangeAspect="1"/>
           </p:cNvPicPr>
@@ -7015,7 +9057,7 @@
                 </a:solidFill>
                 <a:latin typeface="Calibri"/>
               </a:rPr>
-              <a:t>Le classement par voisins communs rebat les cartes</a:t>
+              <a:t>Un petit graphe pondéré</a:t>
             </a:r>
           </a:p>
         </p:txBody>
@@ -7111,14 +9153,14 @@
                 </a:solidFill>
                 <a:latin typeface="Calibri"/>
               </a:rPr>
-              <a:t>Pourquoi l'affinité compte en EDA</a:t>
+              <a:t>L'affinité par poids d'arête classe les paires</a:t>
             </a:r>
           </a:p>
         </p:txBody>
       </p:sp>
       <p:pic>
         <p:nvPicPr>
-          <p:cNvPr id="3" name="Picture 2" descr="05-takeaway.png"/>
+          <p:cNvPr id="3" name="Picture 2" descr="02-edge-rank.png"/>
           <p:cNvPicPr>
             <a:picLocks noChangeAspect="1"/>
           </p:cNvPicPr>
@@ -7174,7 +9216,7 @@
                 </a:solidFill>
                 <a:latin typeface="Calibri"/>
               </a:rPr>
-              <a:t>Pourquoi l'affinité compte en EDA</a:t>
+              <a:t>L'affinité par poids d'arête classe les paires</a:t>
             </a:r>
           </a:p>
         </p:txBody>
@@ -7270,21 +9312,45 @@
                 </a:solidFill>
                 <a:latin typeface="Calibri"/>
               </a:rPr>
-              <a:t>Le score par voisins communs en pseudo-code</a:t>
-            </a:r>
-          </a:p>
-        </p:txBody>
-      </p:sp>
-      <p:sp>
-        <p:nvSpPr>
-          <p:cNvPr id="3" name="TextBox 2"/>
+              <a:t>Les voisins communs renforcent A–B</a:t>
+            </a:r>
+          </a:p>
+        </p:txBody>
+      </p:sp>
+      <p:pic>
+        <p:nvPicPr>
+          <p:cNvPr id="3" name="Picture 2" descr="03-shared-idea.png"/>
+          <p:cNvPicPr>
+            <a:picLocks noChangeAspect="1"/>
+          </p:cNvPicPr>
+          <p:nvPr/>
+        </p:nvPicPr>
+        <p:blipFill>
+          <a:blip r:embed="rId2"/>
+          <a:stretch>
+            <a:fillRect/>
+          </a:stretch>
+        </p:blipFill>
+        <p:spPr>
+          <a:xfrm>
+            <a:off x="548640" y="1143000"/>
+            <a:ext cx="6746750" cy="4572000"/>
+          </a:xfrm>
+          <a:prstGeom prst="rect">
+            <a:avLst/>
+          </a:prstGeom>
+        </p:spPr>
+      </p:pic>
+      <p:sp>
+        <p:nvSpPr>
+          <p:cNvPr id="4" name="TextBox 3"/>
           <p:cNvSpPr txBox="1"/>
           <p:nvPr/>
         </p:nvSpPr>
         <p:spPr>
           <a:xfrm>
-            <a:off x="548640" y="1234440"/>
-            <a:ext cx="11064240" cy="4937760"/>
+            <a:off x="548640" y="5897880"/>
+            <a:ext cx="11064240" cy="411480"/>
           </a:xfrm>
           <a:prstGeom prst="rect">
             <a:avLst/>
@@ -7297,142 +9363,26 @@
           </a:bodyPr>
           <a:lstStyle/>
           <a:p>
-            <a:pPr lvl="0" marL="457200" indent="-228600">
-              <a:buFont typeface="Calibri"/>
-              <a:spcAft>
-                <a:spcPts val="1000"/>
-              </a:spcAft>
-              <a:buSzPct val="100000"/>
-              <a:buChar char="•"/>
-              <a:lnSpc>
-                <a:spcPts val="2200"/>
-              </a:lnSpc>
-            </a:pPr>
-            <a:r>
-              <a:rPr sz="2000" b="0">
+            <a:pPr>
+              <a:lnSpc>
+                <a:spcPts val="2200"/>
+              </a:lnSpc>
+            </a:pPr>
+            <a:r>
+              <a:rPr sz="1200" b="0">
                 <a:solidFill>
                   <a:srgbClr val="333333"/>
                 </a:solidFill>
                 <a:latin typeface="Calibri"/>
               </a:rPr>
-              <a:t>Voici le score par voisins communs sous forme de code</a:t>
-            </a:r>
-          </a:p>
-          <a:p>
-            <a:pPr lvl="0" marL="457200" indent="-228600">
-              <a:buFont typeface="Calibri"/>
-              <a:spcAft>
-                <a:spcPts val="1000"/>
-              </a:spcAft>
-              <a:buSzPct val="100000"/>
-              <a:buChar char="•"/>
-              <a:lnSpc>
-                <a:spcPts val="2200"/>
-              </a:lnSpc>
-            </a:pPr>
-            <a:r>
-              <a:rPr sz="2000" b="0">
-                <a:solidFill>
-                  <a:srgbClr val="333333"/>
-                </a:solidFill>
-                <a:latin typeface="Calibri"/>
-              </a:rPr>
-              <a:t>D'abord, chaque arête existante ajoute son poids à sa paire</a:t>
-            </a:r>
-          </a:p>
-          <a:p>
-            <a:pPr lvl="0" marL="457200" indent="-228600">
-              <a:buFont typeface="Calibri"/>
-              <a:spcAft>
-                <a:spcPts val="1000"/>
-              </a:spcAft>
-              <a:buSzPct val="100000"/>
-              <a:buChar char="•"/>
-              <a:lnSpc>
-                <a:spcPts val="2200"/>
-              </a:lnSpc>
-            </a:pPr>
-            <a:r>
-              <a:rPr sz="2000" b="0">
-                <a:solidFill>
-                  <a:srgbClr val="333333"/>
-                </a:solidFill>
-                <a:latin typeface="Calibri"/>
-              </a:rPr>
-              <a:t>Ensuite, on prend chaque paire de nœuds et chacun de leurs voisins communs</a:t>
-            </a:r>
-          </a:p>
-          <a:p>
-            <a:pPr lvl="0" marL="457200" indent="-228600">
-              <a:buFont typeface="Calibri"/>
-              <a:spcAft>
-                <a:spcPts val="1000"/>
-              </a:spcAft>
-              <a:buSzPct val="100000"/>
-              <a:buChar char="•"/>
-              <a:lnSpc>
-                <a:spcPts val="2200"/>
-              </a:lnSpc>
-            </a:pPr>
-            <a:r>
-              <a:rPr sz="2000" b="0">
-                <a:solidFill>
-                  <a:srgbClr val="333333"/>
-                </a:solidFill>
-                <a:latin typeface="Calibri"/>
-              </a:rPr>
-              <a:t>Pour chaque voisin commun, on ajoute le plus petit des deux poids vers la paire</a:t>
-            </a:r>
-          </a:p>
-          <a:p>
-            <a:pPr lvl="0" marL="457200" indent="-228600">
-              <a:buFont typeface="Calibri"/>
-              <a:spcAft>
-                <a:spcPts val="1000"/>
-              </a:spcAft>
-              <a:buSzPct val="100000"/>
-              <a:buChar char="•"/>
-              <a:lnSpc>
-                <a:spcPts val="2200"/>
-              </a:lnSpc>
-            </a:pPr>
-            <a:r>
-              <a:rPr sz="2000" b="0">
-                <a:solidFill>
-                  <a:srgbClr val="333333"/>
-                </a:solidFill>
-                <a:latin typeface="Calibri"/>
-              </a:rPr>
-              <a:t>Une paire dont le score dépasse zéro est gardée</a:t>
-            </a:r>
-          </a:p>
-          <a:p>
-            <a:pPr lvl="0" marL="457200" indent="-228600">
-              <a:buFont typeface="Calibri"/>
-              <a:spcAft>
-                <a:spcPts val="1000"/>
-              </a:spcAft>
-              <a:buSzPct val="100000"/>
-              <a:buChar char="•"/>
-              <a:lnSpc>
-                <a:spcPts val="2200"/>
-              </a:lnSpc>
-            </a:pPr>
-            <a:r>
-              <a:rPr sz="2000" b="0">
-                <a:solidFill>
-                  <a:srgbClr val="333333"/>
-                </a:solidFill>
-                <a:latin typeface="Calibri"/>
-              </a:rPr>
-              <a:t>Enfin, on trie par score décroissant, et on départage les égalités par ordre alphabétique</a:t>
-            </a:r>
-          </a:p>
-        </p:txBody>
-      </p:sp>
-      <p:sp>
-        <p:nvSpPr>
-          <p:cNvPr id="4" name="TextBox 3"/>
+              <a:t>Les voisins communs renforcent A–B</a:t>
+            </a:r>
+          </a:p>
+        </p:txBody>
+      </p:sp>
+      <p:sp>
+        <p:nvSpPr>
+          <p:cNvPr id="5" name="TextBox 4"/>
           <p:cNvSpPr txBox="1"/>
           <p:nvPr/>
         </p:nvSpPr>
@@ -7521,28 +9471,50 @@
                 </a:solidFill>
                 <a:latin typeface="Calibri"/>
               </a:rPr>
-              <a:t>Le score par voisins communs en pseudo-code — à essayer</a:t>
-            </a:r>
-          </a:p>
-        </p:txBody>
-      </p:sp>
-      <p:sp>
-        <p:nvSpPr>
-          <p:cNvPr id="3" name="TextBox 2"/>
-          <p:cNvSpPr txBox="1"/>
+              <a:t>Le classement par voisins communs rebat les cartes</a:t>
+            </a:r>
+          </a:p>
+        </p:txBody>
+      </p:sp>
+      <p:pic>
+        <p:nvPicPr>
+          <p:cNvPr id="3" name="Picture 2" descr="04-shared-rank.png"/>
+          <p:cNvPicPr>
+            <a:picLocks noChangeAspect="1"/>
+          </p:cNvPicPr>
           <p:nvPr/>
-        </p:nvSpPr>
+        </p:nvPicPr>
+        <p:blipFill>
+          <a:blip r:embed="rId2"/>
+          <a:stretch>
+            <a:fillRect/>
+          </a:stretch>
+        </p:blipFill>
         <p:spPr>
           <a:xfrm>
             <a:off x="548640" y="1143000"/>
-            <a:ext cx="11064240" cy="5029200"/>
+            <a:ext cx="6746750" cy="4572000"/>
           </a:xfrm>
           <a:prstGeom prst="rect">
             <a:avLst/>
           </a:prstGeom>
-          <a:solidFill>
-            <a:srgbClr val="F4F4F4"/>
-          </a:solidFill>
+        </p:spPr>
+      </p:pic>
+      <p:sp>
+        <p:nvSpPr>
+          <p:cNvPr id="4" name="TextBox 3"/>
+          <p:cNvSpPr txBox="1"/>
+          <p:nvPr/>
+        </p:nvSpPr>
+        <p:spPr>
+          <a:xfrm>
+            <a:off x="548640" y="5897880"/>
+            <a:ext cx="11064240" cy="411480"/>
+          </a:xfrm>
+          <a:prstGeom prst="rect">
+            <a:avLst/>
+          </a:prstGeom>
+          <a:noFill/>
         </p:spPr>
         <p:txBody>
           <a:bodyPr wrap="square">
@@ -7554,196 +9526,22 @@
               <a:lnSpc>
                 <a:spcPts val="2200"/>
               </a:lnSpc>
-              <a:spcAft>
-                <a:spcPts val="400"/>
-              </a:spcAft>
-            </a:pPr>
-            <a:r>
-              <a:rPr sz="2000" b="0">
+            </a:pPr>
+            <a:r>
+              <a:rPr sz="1200" b="0">
                 <a:solidFill>
                   <a:srgbClr val="333333"/>
                 </a:solidFill>
-                <a:latin typeface="Consolas"/>
-              </a:rPr>
-              <a:t>affinity_shared_neighbors(nodes, edges):</a:t>
-            </a:r>
-          </a:p>
-          <a:p>
-            <a:pPr>
-              <a:lnSpc>
-                <a:spcPts val="2200"/>
-              </a:lnSpc>
-              <a:spcAft>
-                <a:spcPts val="400"/>
-              </a:spcAft>
-            </a:pPr>
-            <a:r>
-              <a:rPr sz="2000" b="0">
-                <a:solidFill>
-                  <a:srgbClr val="333333"/>
-                </a:solidFill>
-                <a:latin typeface="Consolas"/>
-              </a:rPr>
-              <a:t>  score[u,v] = w(u,v) pour chaque arête</a:t>
-            </a:r>
-          </a:p>
-          <a:p>
-            <a:pPr>
-              <a:lnSpc>
-                <a:spcPts val="2200"/>
-              </a:lnSpc>
-              <a:spcAft>
-                <a:spcPts val="400"/>
-              </a:spcAft>
-            </a:pPr>
-            <a:r>
-              <a:rPr sz="2000" b="0">
-                <a:solidFill>
-                  <a:srgbClr val="333333"/>
-                </a:solidFill>
-                <a:latin typeface="Consolas"/>
-              </a:rPr>
-              <a:t>  pour chaque paire (u, v) de nœuds :</a:t>
-            </a:r>
-          </a:p>
-          <a:p>
-            <a:pPr>
-              <a:lnSpc>
-                <a:spcPts val="2200"/>
-              </a:lnSpc>
-              <a:spcAft>
-                <a:spcPts val="400"/>
-              </a:spcAft>
-            </a:pPr>
-            <a:r>
-              <a:rPr sz="2000" b="0">
-                <a:solidFill>
-                  <a:srgbClr val="333333"/>
-                </a:solidFill>
-                <a:latin typeface="Consolas"/>
-              </a:rPr>
-              <a:t>    s = 0</a:t>
-            </a:r>
-          </a:p>
-          <a:p>
-            <a:pPr>
-              <a:lnSpc>
-                <a:spcPts val="2200"/>
-              </a:lnSpc>
-              <a:spcAft>
-                <a:spcPts val="400"/>
-              </a:spcAft>
-            </a:pPr>
-            <a:r>
-              <a:rPr sz="2000" b="0">
-                <a:solidFill>
-                  <a:srgbClr val="333333"/>
-                </a:solidFill>
-                <a:latin typeface="Consolas"/>
-              </a:rPr>
-              <a:t>    pour x dans voisins(u), x != v :</a:t>
-            </a:r>
-          </a:p>
-          <a:p>
-            <a:pPr>
-              <a:lnSpc>
-                <a:spcPts val="2200"/>
-              </a:lnSpc>
-              <a:spcAft>
-                <a:spcPts val="400"/>
-              </a:spcAft>
-            </a:pPr>
-            <a:r>
-              <a:rPr sz="2000" b="0">
-                <a:solidFill>
-                  <a:srgbClr val="333333"/>
-                </a:solidFill>
-                <a:latin typeface="Consolas"/>
-              </a:rPr>
-              <a:t>      si x dans voisins(v) :</a:t>
-            </a:r>
-          </a:p>
-          <a:p>
-            <a:pPr>
-              <a:lnSpc>
-                <a:spcPts val="2200"/>
-              </a:lnSpc>
-              <a:spcAft>
-                <a:spcPts val="400"/>
-              </a:spcAft>
-            </a:pPr>
-            <a:r>
-              <a:rPr sz="2000" b="0">
-                <a:solidFill>
-                  <a:srgbClr val="333333"/>
-                </a:solidFill>
-                <a:latin typeface="Consolas"/>
-              </a:rPr>
-              <a:t>        s += min(w(u,x), w(v,x))</a:t>
-            </a:r>
-          </a:p>
-          <a:p>
-            <a:pPr>
-              <a:lnSpc>
-                <a:spcPts val="2200"/>
-              </a:lnSpc>
-              <a:spcAft>
-                <a:spcPts val="400"/>
-              </a:spcAft>
-            </a:pPr>
-            <a:r>
-              <a:rPr sz="2000" b="0">
-                <a:solidFill>
-                  <a:srgbClr val="333333"/>
-                </a:solidFill>
-                <a:latin typeface="Consolas"/>
-              </a:rPr>
-              <a:t>    si s &gt; 0 ou (u,v) a une arête :</a:t>
-            </a:r>
-          </a:p>
-          <a:p>
-            <a:pPr>
-              <a:lnSpc>
-                <a:spcPts val="2200"/>
-              </a:lnSpc>
-              <a:spcAft>
-                <a:spcPts val="400"/>
-              </a:spcAft>
-            </a:pPr>
-            <a:r>
-              <a:rPr sz="2000" b="0">
-                <a:solidFill>
-                  <a:srgbClr val="333333"/>
-                </a:solidFill>
-                <a:latin typeface="Consolas"/>
-              </a:rPr>
-              <a:t>      score[u,v] += s</a:t>
-            </a:r>
-          </a:p>
-          <a:p>
-            <a:pPr>
-              <a:lnSpc>
-                <a:spcPts val="2200"/>
-              </a:lnSpc>
-              <a:spcAft>
-                <a:spcPts val="400"/>
-              </a:spcAft>
-            </a:pPr>
-            <a:r>
-              <a:rPr sz="2000" b="0">
-                <a:solidFill>
-                  <a:srgbClr val="333333"/>
-                </a:solidFill>
-                <a:latin typeface="Consolas"/>
-              </a:rPr>
-              <a:t>  trier par score (décroissant), puis u, puis v</a:t>
-            </a:r>
-          </a:p>
-        </p:txBody>
-      </p:sp>
-      <p:sp>
-        <p:nvSpPr>
-          <p:cNvPr id="4" name="TextBox 3"/>
+                <a:latin typeface="Calibri"/>
+              </a:rPr>
+              <a:t>Le classement par voisins communs rebat les cartes</a:t>
+            </a:r>
+          </a:p>
+        </p:txBody>
+      </p:sp>
+      <p:sp>
+        <p:nvSpPr>
+          <p:cNvPr id="5" name="TextBox 4"/>
           <p:cNvSpPr txBox="1"/>
           <p:nvPr/>
         </p:nvSpPr>
@@ -7832,21 +9630,45 @@
                 </a:solidFill>
                 <a:latin typeface="Calibri"/>
               </a:rPr>
-              <a:t>Dix paires, pas six</a:t>
-            </a:r>
-          </a:p>
-        </p:txBody>
-      </p:sp>
-      <p:sp>
-        <p:nvSpPr>
-          <p:cNvPr id="3" name="TextBox 2"/>
+              <a:t>Pourquoi l'affinité compte en EDA</a:t>
+            </a:r>
+          </a:p>
+        </p:txBody>
+      </p:sp>
+      <p:pic>
+        <p:nvPicPr>
+          <p:cNvPr id="3" name="Picture 2" descr="05-takeaway.png"/>
+          <p:cNvPicPr>
+            <a:picLocks noChangeAspect="1"/>
+          </p:cNvPicPr>
+          <p:nvPr/>
+        </p:nvPicPr>
+        <p:blipFill>
+          <a:blip r:embed="rId2"/>
+          <a:stretch>
+            <a:fillRect/>
+          </a:stretch>
+        </p:blipFill>
+        <p:spPr>
+          <a:xfrm>
+            <a:off x="548640" y="1143000"/>
+            <a:ext cx="6746750" cy="4572000"/>
+          </a:xfrm>
+          <a:prstGeom prst="rect">
+            <a:avLst/>
+          </a:prstGeom>
+        </p:spPr>
+      </p:pic>
+      <p:sp>
+        <p:nvSpPr>
+          <p:cNvPr id="4" name="TextBox 3"/>
           <p:cNvSpPr txBox="1"/>
           <p:nvPr/>
         </p:nvSpPr>
         <p:spPr>
           <a:xfrm>
-            <a:off x="548640" y="1234440"/>
-            <a:ext cx="11064240" cy="4937760"/>
+            <a:off x="548640" y="5897880"/>
+            <a:ext cx="11064240" cy="411480"/>
           </a:xfrm>
           <a:prstGeom prst="rect">
             <a:avLst/>
@@ -7859,142 +9681,26 @@
           </a:bodyPr>
           <a:lstStyle/>
           <a:p>
-            <a:pPr lvl="0" marL="457200" indent="-228600">
-              <a:buFont typeface="Calibri"/>
-              <a:spcAft>
-                <a:spcPts val="1000"/>
-              </a:spcAft>
-              <a:buSzPct val="100000"/>
-              <a:buChar char="•"/>
-              <a:lnSpc>
-                <a:spcPts val="2200"/>
-              </a:lnSpc>
-            </a:pPr>
-            <a:r>
-              <a:rPr sz="2000" b="0">
+            <a:pPr>
+              <a:lnSpc>
+                <a:spcPts val="2200"/>
+              </a:lnSpc>
+            </a:pPr>
+            <a:r>
+              <a:rPr sz="1200" b="0">
                 <a:solidFill>
                   <a:srgbClr val="333333"/>
                 </a:solidFill>
                 <a:latin typeface="Calibri"/>
               </a:rPr>
-              <a:t>Avec le score par voisins communs, le graphe de départ donne dix paires, et non six</a:t>
-            </a:r>
-          </a:p>
-          <a:p>
-            <a:pPr lvl="0" marL="457200" indent="-228600">
-              <a:buFont typeface="Calibri"/>
-              <a:spcAft>
-                <a:spcPts val="1000"/>
-              </a:spcAft>
-              <a:buSzPct val="100000"/>
-              <a:buChar char="•"/>
-              <a:lnSpc>
-                <a:spcPts val="2200"/>
-              </a:lnSpc>
-            </a:pPr>
-            <a:r>
-              <a:rPr sz="2000" b="0">
-                <a:solidFill>
-                  <a:srgbClr val="333333"/>
-                </a:solidFill>
-                <a:latin typeface="Calibri"/>
-              </a:rPr>
-              <a:t>Quatre d'entre elles n'ont aucune arête</a:t>
-            </a:r>
-          </a:p>
-          <a:p>
-            <a:pPr lvl="0" marL="457200" indent="-228600">
-              <a:buFont typeface="Calibri"/>
-              <a:spcAft>
-                <a:spcPts val="1000"/>
-              </a:spcAft>
-              <a:buSzPct val="100000"/>
-              <a:buChar char="•"/>
-              <a:lnSpc>
-                <a:spcPts val="2200"/>
-              </a:lnSpc>
-            </a:pPr>
-            <a:r>
-              <a:rPr sz="2000" b="0">
-                <a:solidFill>
-                  <a:srgbClr val="333333"/>
-                </a:solidFill>
-                <a:latin typeface="Calibri"/>
-              </a:rPr>
-              <a:t>B et D sont tous les deux reliés à C, donc B–D obtient le plus petit rayon : deux</a:t>
-            </a:r>
-          </a:p>
-          <a:p>
-            <a:pPr lvl="0" marL="457200" indent="-228600">
-              <a:buFont typeface="Calibri"/>
-              <a:spcAft>
-                <a:spcPts val="1000"/>
-              </a:spcAft>
-              <a:buSzPct val="100000"/>
-              <a:buChar char="•"/>
-              <a:lnSpc>
-                <a:spcPts val="2200"/>
-              </a:lnSpc>
-            </a:pPr>
-            <a:r>
-              <a:rPr sz="2000" b="0">
-                <a:solidFill>
-                  <a:srgbClr val="333333"/>
-                </a:solidFill>
-                <a:latin typeface="Calibri"/>
-              </a:rPr>
-              <a:t>A–D, A–E et B–E gagnent chacune un, en passant par C</a:t>
-            </a:r>
-          </a:p>
-          <a:p>
-            <a:pPr lvl="0" marL="457200" indent="-228600">
-              <a:buFont typeface="Calibri"/>
-              <a:spcAft>
-                <a:spcPts val="1000"/>
-              </a:spcAft>
-              <a:buSzPct val="100000"/>
-              <a:buChar char="•"/>
-              <a:lnSpc>
-                <a:spcPts val="2200"/>
-              </a:lnSpc>
-            </a:pPr>
-            <a:r>
-              <a:rPr sz="2000" b="0">
-                <a:solidFill>
-                  <a:srgbClr val="333333"/>
-                </a:solidFill>
-                <a:latin typeface="Calibri"/>
-              </a:rPr>
-              <a:t>Ces paires ne sont pas des erreurs</a:t>
-            </a:r>
-          </a:p>
-          <a:p>
-            <a:pPr lvl="0" marL="457200" indent="-228600">
-              <a:buFont typeface="Calibri"/>
-              <a:spcAft>
-                <a:spcPts val="1000"/>
-              </a:spcAft>
-              <a:buSzPct val="100000"/>
-              <a:buChar char="•"/>
-              <a:lnSpc>
-                <a:spcPts val="2200"/>
-              </a:lnSpc>
-            </a:pPr>
-            <a:r>
-              <a:rPr sz="2000" b="0">
-                <a:solidFill>
-                  <a:srgbClr val="333333"/>
-                </a:solidFill>
-                <a:latin typeface="Calibri"/>
-              </a:rPr>
-              <a:t>Elles disent que deux cellules sont proches, même sans fil direct</a:t>
-            </a:r>
-          </a:p>
-        </p:txBody>
-      </p:sp>
-      <p:sp>
-        <p:nvSpPr>
-          <p:cNvPr id="4" name="TextBox 3"/>
+              <a:t>Pourquoi l'affinité compte en EDA</a:t>
+            </a:r>
+          </a:p>
+        </p:txBody>
+      </p:sp>
+      <p:sp>
+        <p:nvSpPr>
+          <p:cNvPr id="5" name="TextBox 4"/>
           <p:cNvSpPr txBox="1"/>
           <p:nvPr/>
         </p:nvSpPr>

</xml_diff>